<commit_message>
feat(mplads): complete 128k eSAKSHI ML pipeline, Google Maps risk heatmap, eSAKSHI UI overhaul & technical whitepaper report
</commit_message>
<xml_diff>
--- a/SIH2026-IDEA-Presentation-Format.pptx
+++ b/SIH2026-IDEA-Presentation-Format.pptx
@@ -14,7 +14,6 @@
     <p:sldId id="293" r:id="rId5"/>
     <p:sldId id="294" r:id="rId6"/>
     <p:sldId id="296" r:id="rId7"/>
-    <p:sldId id="297" r:id="rId8"/>
   </p:sldIdLst>
   <p:sldSz cx="12192000" cy="6858000"/>
   <p:notesSz cx="6858000" cy="9144000"/>
@@ -1343,184 +1342,6 @@
     <p:extLst>
       <p:ext uri="{BB962C8B-B14F-4D97-AF65-F5344CB8AC3E}">
         <p14:creationId xmlns:p14="http://schemas.microsoft.com/office/powerpoint/2010/main" val="1908672725"/>
-      </p:ext>
-    </p:extLst>
-  </p:cSld>
-  <p:clrMapOvr>
-    <a:masterClrMapping/>
-  </p:clrMapOvr>
-</p:notes>
-</file>
-
-<file path=ppt/notesSlides/notesSlide6.xml><?xml version="1.0" encoding="utf-8"?>
-<p:notes xmlns:a="http://schemas.openxmlformats.org/drawingml/2006/main" xmlns:r="http://schemas.openxmlformats.org/officeDocument/2006/relationships" xmlns:p="http://schemas.openxmlformats.org/presentationml/2006/main">
-  <p:cSld>
-    <p:spTree>
-      <p:nvGrpSpPr>
-        <p:cNvPr id="1" name=""/>
-        <p:cNvGrpSpPr/>
-        <p:nvPr/>
-      </p:nvGrpSpPr>
-      <p:grpSpPr>
-        <a:xfrm>
-          <a:off x="0" y="0"/>
-          <a:ext cx="0" cy="0"/>
-          <a:chOff x="0" y="0"/>
-          <a:chExt cx="0" cy="0"/>
-        </a:xfrm>
-      </p:grpSpPr>
-      <p:sp>
-        <p:nvSpPr>
-          <p:cNvPr id="18433" name="Slide Image Placeholder 1"/>
-          <p:cNvSpPr>
-            <a:spLocks noGrp="1" noRot="1" noChangeAspect="1"/>
-          </p:cNvSpPr>
-          <p:nvPr>
-            <p:ph type="sldImg"/>
-          </p:nvPr>
-        </p:nvSpPr>
-        <p:spPr bwMode="auto">
-          <a:xfrm>
-            <a:off x="381000" y="685800"/>
-            <a:ext cx="6096000" cy="3429000"/>
-          </a:xfrm>
-          <a:noFill/>
-          <a:ln>
-            <a:solidFill>
-              <a:srgbClr val="000000"/>
-            </a:solidFill>
-            <a:miter lim="800000"/>
-            <a:headEnd/>
-            <a:tailEnd/>
-          </a:ln>
-        </p:spPr>
-      </p:sp>
-      <p:sp>
-        <p:nvSpPr>
-          <p:cNvPr id="18434" name="Notes Placeholder 2"/>
-          <p:cNvSpPr>
-            <a:spLocks noGrp="1"/>
-          </p:cNvSpPr>
-          <p:nvPr>
-            <p:ph type="body" idx="1"/>
-          </p:nvPr>
-        </p:nvSpPr>
-        <p:spPr bwMode="auto">
-          <a:noFill/>
-        </p:spPr>
-        <p:txBody>
-          <a:bodyPr wrap="square" numCol="1" anchor="t" anchorCtr="0" compatLnSpc="1">
-            <a:prstTxWarp prst="textNoShape">
-              <a:avLst/>
-            </a:prstTxWarp>
-          </a:bodyPr>
-          <a:lstStyle/>
-          <a:p>
-            <a:pPr eaLnBrk="1" hangingPunct="1">
-              <a:spcBef>
-                <a:spcPct val="0"/>
-              </a:spcBef>
-            </a:pPr>
-            <a:endParaRPr lang="en-US">
-              <a:ea typeface="ＭＳ Ｐゴシック" pitchFamily="1" charset="-128"/>
-            </a:endParaRPr>
-          </a:p>
-        </p:txBody>
-      </p:sp>
-      <p:sp>
-        <p:nvSpPr>
-          <p:cNvPr id="18435" name="Slide Number Placeholder 3"/>
-          <p:cNvSpPr>
-            <a:spLocks noGrp="1"/>
-          </p:cNvSpPr>
-          <p:nvPr>
-            <p:ph type="sldNum" sz="quarter" idx="5"/>
-          </p:nvPr>
-        </p:nvSpPr>
-        <p:spPr bwMode="auto">
-          <a:noFill/>
-          <a:ln>
-            <a:miter lim="800000"/>
-            <a:headEnd/>
-            <a:tailEnd/>
-          </a:ln>
-        </p:spPr>
-        <p:txBody>
-          <a:bodyPr/>
-          <a:lstStyle/>
-          <a:p>
-            <a:pPr marL="0" marR="0" lvl="0" indent="0" algn="r" defTabSz="457200" rtl="0" eaLnBrk="1" fontAlgn="base" latinLnBrk="0" hangingPunct="1">
-              <a:lnSpc>
-                <a:spcPct val="100000"/>
-              </a:lnSpc>
-              <a:spcBef>
-                <a:spcPct val="0"/>
-              </a:spcBef>
-              <a:spcAft>
-                <a:spcPct val="0"/>
-              </a:spcAft>
-              <a:buClrTx/>
-              <a:buSzTx/>
-              <a:buFontTx/>
-              <a:buNone/>
-              <a:tabLst/>
-              <a:defRPr/>
-            </a:pPr>
-            <a:fld id="{0CA7B74D-3791-4AC6-8451-F10DBCCCDD9A}" type="slidenum">
-              <a:rPr kumimoji="0" lang="en-US" sz="1200" b="0" i="0" u="none" strike="noStrike" kern="1200" cap="none" spc="0" normalizeH="0" baseline="0" noProof="0">
-                <a:ln>
-                  <a:noFill/>
-                </a:ln>
-                <a:solidFill>
-                  <a:prstClr val="black"/>
-                </a:solidFill>
-                <a:effectLst/>
-                <a:uLnTx/>
-                <a:uFillTx/>
-                <a:latin typeface="Calibri" pitchFamily="34" charset="0"/>
-                <a:ea typeface="ＭＳ Ｐゴシック" pitchFamily="1" charset="-128"/>
-                <a:cs typeface="+mn-cs"/>
-              </a:rPr>
-              <a:pPr marL="0" marR="0" lvl="0" indent="0" algn="r" defTabSz="457200" rtl="0" eaLnBrk="1" fontAlgn="base" latinLnBrk="0" hangingPunct="1">
-                <a:lnSpc>
-                  <a:spcPct val="100000"/>
-                </a:lnSpc>
-                <a:spcBef>
-                  <a:spcPct val="0"/>
-                </a:spcBef>
-                <a:spcAft>
-                  <a:spcPct val="0"/>
-                </a:spcAft>
-                <a:buClrTx/>
-                <a:buSzTx/>
-                <a:buFontTx/>
-                <a:buNone/>
-                <a:tabLst/>
-                <a:defRPr/>
-              </a:pPr>
-              <a:t>7</a:t>
-            </a:fld>
-            <a:endParaRPr kumimoji="0" lang="en-US" sz="1200" b="0" i="0" u="none" strike="noStrike" kern="1200" cap="none" spc="0" normalizeH="0" baseline="0" noProof="0">
-              <a:ln>
-                <a:noFill/>
-              </a:ln>
-              <a:solidFill>
-                <a:prstClr val="black"/>
-              </a:solidFill>
-              <a:effectLst/>
-              <a:uLnTx/>
-              <a:uFillTx/>
-              <a:latin typeface="Calibri" pitchFamily="34" charset="0"/>
-              <a:ea typeface="ＭＳ Ｐゴシック" pitchFamily="1" charset="-128"/>
-              <a:cs typeface="+mn-cs"/>
-            </a:endParaRPr>
-          </a:p>
-        </p:txBody>
-      </p:sp>
-    </p:spTree>
-    <p:extLst>
-      <p:ext uri="{BB962C8B-B14F-4D97-AF65-F5344CB8AC3E}">
-        <p14:creationId xmlns:p14="http://schemas.microsoft.com/office/powerpoint/2010/main" val="3783576877"/>
       </p:ext>
     </p:extLst>
   </p:cSld>
@@ -5727,6 +5548,14 @@
           <a:bodyPr/>
           <a:lstStyle/>
           <a:p>
+            <a:r>
+              <a:rPr sz="1600" b="1">
+                <a:solidFill>
+                  <a:srgbClr val="002147"/>
+                </a:solidFill>
+              </a:rPr>
+              <a:t>AI-Powered MPLADS Anomaly, Fraud &amp; Inefficiency Detection Platform</a:t>
+            </a:r>
             <a:endParaRPr lang="en-US" b="1" dirty="0">
               <a:solidFill>
                 <a:schemeClr val="tx1"/>
@@ -5736,23 +5565,22 @@
             </a:endParaRPr>
           </a:p>
           <a:p>
-            <a:r>
-              <a:rPr lang="en-US" b="1" dirty="0">
-                <a:solidFill>
-                  <a:schemeClr val="tx1"/>
-                </a:solidFill>
-                <a:latin typeface="Times New Roman" panose="02020603050405020304" pitchFamily="18" charset="0"/>
-                <a:cs typeface="Times New Roman" panose="02020603050405020304" pitchFamily="18" charset="0"/>
-              </a:rPr>
-              <a:t>TITLE PAGE</a:t>
-            </a:r>
-            <a:endParaRPr lang="en-IN" b="1" dirty="0">
-              <a:solidFill>
-                <a:schemeClr val="tx1"/>
-              </a:solidFill>
-              <a:latin typeface="Times New Roman" panose="02020603050405020304" pitchFamily="18" charset="0"/>
-              <a:cs typeface="Times New Roman" panose="02020603050405020304" pitchFamily="18" charset="0"/>
-            </a:endParaRPr>
+            <a:pPr>
+              <a:spcBef>
+                <a:spcPts val="600"/>
+              </a:spcBef>
+              <a:spcAft>
+                <a:spcPts val="200"/>
+              </a:spcAft>
+            </a:pPr>
+            <a:r>
+              <a:rPr sz="1300" b="0">
+                <a:solidFill>
+                  <a:srgbClr val="007B83"/>
+                </a:solidFill>
+              </a:rPr>
+              <a:t>Intelligent Decision-Support Overlay for eSAKSHI</a:t>
+            </a:r>
           </a:p>
         </p:txBody>
       </p:sp>
@@ -5825,107 +5653,167 @@
           </a:bodyPr>
           <a:lstStyle/>
           <a:p>
+            <a:r>
+              <a:rPr sz="200" b="0"/>
+              <a:t/>
+            </a:r>
             <a:endParaRPr lang="en-US" dirty="0"/>
           </a:p>
           <a:p>
-            <a:pPr marL="285750" indent="-285750" algn="just">
-              <a:lnSpc>
-                <a:spcPct val="200000"/>
-              </a:lnSpc>
-              <a:buFont typeface="Arial" panose="020B0604020202020204" pitchFamily="34" charset="0"/>
-              <a:buChar char="•"/>
-            </a:pPr>
-            <a:r>
-              <a:rPr lang="en-US" sz="2400" b="1" dirty="0">
-                <a:latin typeface="Arial" panose="020B0604020202020204" pitchFamily="34" charset="0"/>
-                <a:cs typeface="Arial" panose="020B0604020202020204" pitchFamily="34" charset="0"/>
-              </a:rPr>
-              <a:t>Problem Statement ID –</a:t>
-            </a:r>
-          </a:p>
-          <a:p>
-            <a:pPr marL="285750" indent="-285750" algn="just">
-              <a:lnSpc>
-                <a:spcPct val="200000"/>
-              </a:lnSpc>
-              <a:buFont typeface="Arial" panose="020B0604020202020204" pitchFamily="34" charset="0"/>
-              <a:buChar char="•"/>
-            </a:pPr>
-            <a:r>
-              <a:rPr lang="en-US" sz="2400" b="1" dirty="0">
-                <a:latin typeface="Arial" panose="020B0604020202020204" pitchFamily="34" charset="0"/>
-                <a:cs typeface="Arial" panose="020B0604020202020204" pitchFamily="34" charset="0"/>
-              </a:rPr>
-              <a:t>Problem Statement Title-</a:t>
-            </a:r>
-          </a:p>
-          <a:p>
-            <a:pPr marL="285750" indent="-285750" algn="just">
-              <a:lnSpc>
-                <a:spcPct val="200000"/>
-              </a:lnSpc>
-              <a:buFont typeface="Arial" panose="020B0604020202020204" pitchFamily="34" charset="0"/>
-              <a:buChar char="•"/>
-            </a:pPr>
-            <a:r>
-              <a:rPr lang="en-US" sz="2400" b="1" dirty="0">
-                <a:latin typeface="Arial" panose="020B0604020202020204" pitchFamily="34" charset="0"/>
-                <a:cs typeface="Arial" panose="020B0604020202020204" pitchFamily="34" charset="0"/>
-              </a:rPr>
-              <a:t>Theme-</a:t>
-            </a:r>
-          </a:p>
-          <a:p>
-            <a:pPr marL="285750" indent="-285750" algn="just">
-              <a:lnSpc>
-                <a:spcPct val="200000"/>
-              </a:lnSpc>
-              <a:buFont typeface="Arial" panose="020B0604020202020204" pitchFamily="34" charset="0"/>
-              <a:buChar char="•"/>
-            </a:pPr>
-            <a:r>
-              <a:rPr lang="en-US" sz="2400" b="1" dirty="0">
-                <a:latin typeface="Arial" panose="020B0604020202020204" pitchFamily="34" charset="0"/>
-                <a:cs typeface="Arial" panose="020B0604020202020204" pitchFamily="34" charset="0"/>
-              </a:rPr>
-              <a:t>PS Category- Software/Hardware</a:t>
-            </a:r>
-          </a:p>
-          <a:p>
-            <a:pPr marL="285750" indent="-285750" algn="just">
-              <a:lnSpc>
-                <a:spcPct val="200000"/>
-              </a:lnSpc>
-              <a:buFont typeface="Arial" panose="020B0604020202020204" pitchFamily="34" charset="0"/>
-              <a:buChar char="•"/>
-            </a:pPr>
-            <a:r>
-              <a:rPr lang="en-US" sz="2400" b="1" dirty="0">
-                <a:latin typeface="Arial" panose="020B0604020202020204" pitchFamily="34" charset="0"/>
-                <a:cs typeface="Arial" panose="020B0604020202020204" pitchFamily="34" charset="0"/>
-              </a:rPr>
-              <a:t>Team ID-</a:t>
-            </a:r>
-          </a:p>
-          <a:p>
-            <a:pPr marL="285750" indent="-285750" algn="just">
-              <a:lnSpc>
-                <a:spcPct val="200000"/>
-              </a:lnSpc>
-              <a:buFont typeface="Arial" panose="020B0604020202020204" pitchFamily="34" charset="0"/>
-              <a:buChar char="•"/>
-            </a:pPr>
-            <a:r>
-              <a:rPr lang="en-US" sz="2400" b="1" dirty="0">
-                <a:latin typeface="Arial" panose="020B0604020202020204" pitchFamily="34" charset="0"/>
-                <a:cs typeface="Arial" panose="020B0604020202020204" pitchFamily="34" charset="0"/>
-              </a:rPr>
-              <a:t>Team Name (Registered on portal)</a:t>
-            </a:r>
-            <a:endParaRPr lang="en-IN" sz="2400" b="1" dirty="0">
-              <a:latin typeface="Arial" panose="020B0604020202020204" pitchFamily="34" charset="0"/>
-              <a:cs typeface="Arial" panose="020B0604020202020204" pitchFamily="34" charset="0"/>
-            </a:endParaRPr>
+            <a:pPr>
+              <a:spcBef>
+                <a:spcPts val="300"/>
+              </a:spcBef>
+              <a:spcAft>
+                <a:spcPts val="100"/>
+              </a:spcAft>
+            </a:pPr>
+            <a:r>
+              <a:rPr sz="1100" b="1">
+                <a:solidFill>
+                  <a:srgbClr val="002147"/>
+                </a:solidFill>
+              </a:rPr>
+              <a:t>Problem Statement ID — </a:t>
+            </a:r>
+            <a:r>
+              <a:rPr sz="1100" b="0">
+                <a:solidFill>
+                  <a:srgbClr val="4A4A4A"/>
+                </a:solidFill>
+              </a:rPr>
+              <a:t>PS-102</a:t>
+            </a:r>
+          </a:p>
+          <a:p>
+            <a:pPr>
+              <a:spcBef>
+                <a:spcPts val="300"/>
+              </a:spcBef>
+              <a:spcAft>
+                <a:spcPts val="100"/>
+              </a:spcAft>
+            </a:pPr>
+            <a:r>
+              <a:rPr sz="1100" b="1">
+                <a:solidFill>
+                  <a:srgbClr val="002147"/>
+                </a:solidFill>
+              </a:rPr>
+              <a:t>Problem Statement Title — </a:t>
+            </a:r>
+            <a:r>
+              <a:rPr sz="1100" b="0">
+                <a:solidFill>
+                  <a:srgbClr val="4A4A4A"/>
+                </a:solidFill>
+              </a:rPr>
+              <a:t>Development of AI/ML-Based System for Enhancing Monitoring of MPLADS Scheme</a:t>
+            </a:r>
+          </a:p>
+          <a:p>
+            <a:pPr>
+              <a:spcBef>
+                <a:spcPts val="300"/>
+              </a:spcBef>
+              <a:spcAft>
+                <a:spcPts val="100"/>
+              </a:spcAft>
+            </a:pPr>
+            <a:r>
+              <a:rPr sz="1100" b="1">
+                <a:solidFill>
+                  <a:srgbClr val="002147"/>
+                </a:solidFill>
+              </a:rPr>
+              <a:t>Theme — </a:t>
+            </a:r>
+            <a:r>
+              <a:rPr sz="1100" b="0">
+                <a:solidFill>
+                  <a:srgbClr val="4A4A4A"/>
+                </a:solidFill>
+              </a:rPr>
+              <a:t>Smart Automation</a:t>
+            </a:r>
+          </a:p>
+          <a:p>
+            <a:pPr>
+              <a:spcBef>
+                <a:spcPts val="300"/>
+              </a:spcBef>
+              <a:spcAft>
+                <a:spcPts val="100"/>
+              </a:spcAft>
+            </a:pPr>
+            <a:r>
+              <a:rPr sz="1100" b="1">
+                <a:solidFill>
+                  <a:srgbClr val="002147"/>
+                </a:solidFill>
+              </a:rPr>
+              <a:t>PS Category — </a:t>
+            </a:r>
+            <a:r>
+              <a:rPr sz="1100" b="0">
+                <a:solidFill>
+                  <a:srgbClr val="4A4A4A"/>
+                </a:solidFill>
+              </a:rPr>
+              <a:t>Software</a:t>
+            </a:r>
+          </a:p>
+          <a:p>
+            <a:pPr>
+              <a:spcBef>
+                <a:spcPts val="300"/>
+              </a:spcBef>
+              <a:spcAft>
+                <a:spcPts val="100"/>
+              </a:spcAft>
+            </a:pPr>
+            <a:r>
+              <a:rPr sz="1100" b="1">
+                <a:solidFill>
+                  <a:srgbClr val="002147"/>
+                </a:solidFill>
+              </a:rPr>
+              <a:t>Team ID — </a:t>
+            </a:r>
+            <a:r>
+              <a:rPr sz="1100" b="0">
+                <a:solidFill>
+                  <a:srgbClr val="4A4A4A"/>
+                </a:solidFill>
+              </a:rPr>
+              <a:t>[To be assigned on portal]</a:t>
+            </a:r>
+          </a:p>
+          <a:p>
+            <a:pPr>
+              <a:spcBef>
+                <a:spcPts val="300"/>
+              </a:spcBef>
+              <a:spcAft>
+                <a:spcPts val="100"/>
+              </a:spcAft>
+            </a:pPr>
+            <a:r>
+              <a:rPr sz="1100" b="1">
+                <a:solidFill>
+                  <a:srgbClr val="002147"/>
+                </a:solidFill>
+              </a:rPr>
+              <a:t>Team Name — </a:t>
+            </a:r>
+            <a:r>
+              <a:rPr sz="1100" b="0">
+                <a:solidFill>
+                  <a:srgbClr val="4A4A4A"/>
+                </a:solidFill>
+              </a:rPr>
+              <a:t>[To be updated]</a:t>
+            </a:r>
           </a:p>
         </p:txBody>
       </p:sp>
@@ -6063,14 +5951,6 @@
           <a:lstStyle/>
           <a:p>
             <a:pPr eaLnBrk="1" hangingPunct="1"/>
-            <a:r>
-              <a:rPr lang="en-US" sz="3600" b="1" dirty="0">
-                <a:latin typeface="Times New Roman" panose="02020603050405020304" pitchFamily="18" charset="0"/>
-                <a:ea typeface="ＭＳ Ｐゴシック" pitchFamily="1" charset="-128"/>
-                <a:cs typeface="Times New Roman" panose="02020603050405020304" pitchFamily="18" charset="0"/>
-              </a:rPr>
-              <a:t/>
-            </a:r>
             <a:br>
               <a:rPr lang="en-US" sz="3600" b="1" dirty="0">
                 <a:latin typeface="Times New Roman" panose="02020603050405020304" pitchFamily="18" charset="0"/>
@@ -6079,12 +5959,8 @@
               </a:rPr>
             </a:br>
             <a:r>
-              <a:rPr lang="en-US" sz="3600" b="1" dirty="0">
-                <a:latin typeface="Times New Roman" panose="02020603050405020304" pitchFamily="18" charset="0"/>
-                <a:ea typeface="ＭＳ Ｐゴシック" pitchFamily="1" charset="-128"/>
-                <a:cs typeface="Times New Roman" panose="02020603050405020304" pitchFamily="18" charset="0"/>
-              </a:rPr>
-              <a:t>IDEA TITLE</a:t>
+              <a:rPr sz="2200" b="1"/>
+              <a:t>AI-POWERED MPLADS ANOMALY &amp; FRAUD DETECTION PLATFORM</a:t>
             </a:r>
           </a:p>
         </p:txBody>
@@ -6124,14 +6000,12 @@
               <a:buChar char="v"/>
             </a:pPr>
             <a:r>
-              <a:rPr lang="en-US" sz="3200" b="1" u="sng" dirty="0">
-                <a:solidFill>
-                  <a:schemeClr val="tx2"/>
-                </a:solidFill>
-                <a:latin typeface="Arial" pitchFamily="34" charset="0"/>
-                <a:cs typeface="Arial" pitchFamily="34" charset="0"/>
-              </a:rPr>
-              <a:t>Proposed Solution (Describe your Idea/Solution/Prototype)</a:t>
+              <a:rPr sz="1100" b="1">
+                <a:solidFill>
+                  <a:srgbClr val="002147"/>
+                </a:solidFill>
+              </a:rPr>
+              <a:t>Proposed Solution — MPLADS AI RiskIntel Platform</a:t>
             </a:r>
             <a:endParaRPr lang="en-US" sz="3200" u="sng" dirty="0">
               <a:solidFill>
@@ -6142,68 +6016,273 @@
             </a:endParaRPr>
           </a:p>
           <a:p>
-            <a:pPr marL="342900" indent="-342900">
-              <a:buFont typeface="Arial" panose="020B0604020202020204" pitchFamily="34" charset="0"/>
-              <a:buChar char="•"/>
-            </a:pPr>
-            <a:endParaRPr lang="en-US" sz="2000" u="sng" dirty="0">
-              <a:solidFill>
-                <a:schemeClr val="tx2"/>
-              </a:solidFill>
-              <a:latin typeface="Arial" pitchFamily="34" charset="0"/>
-              <a:cs typeface="Arial" pitchFamily="34" charset="0"/>
-            </a:endParaRPr>
-          </a:p>
-          <a:p>
-            <a:pPr marL="342900" indent="-342900">
-              <a:buFont typeface="Arial" panose="020B0604020202020204" pitchFamily="34" charset="0"/>
-              <a:buChar char="•"/>
-            </a:pPr>
-            <a:endParaRPr lang="en-US" sz="2000" u="sng" dirty="0">
-              <a:solidFill>
-                <a:schemeClr val="tx2"/>
-              </a:solidFill>
-              <a:latin typeface="Arial" pitchFamily="34" charset="0"/>
-              <a:cs typeface="Arial" pitchFamily="34" charset="0"/>
-            </a:endParaRPr>
-          </a:p>
-          <a:p>
-            <a:pPr marL="342900" indent="-342900" algn="just">
-              <a:buFont typeface="Arial" panose="020B0604020202020204" pitchFamily="34" charset="0"/>
-              <a:buChar char="•"/>
-            </a:pPr>
-            <a:r>
-              <a:rPr lang="en-US" sz="2800" dirty="0">
-                <a:latin typeface="Arial" pitchFamily="34" charset="0"/>
-                <a:cs typeface="Arial" pitchFamily="34" charset="0"/>
-              </a:rPr>
-              <a:t>Detailed explanation of the proposed solution</a:t>
-            </a:r>
-          </a:p>
-          <a:p>
-            <a:pPr marL="342900" indent="-342900" algn="just">
-              <a:buFont typeface="Arial" panose="020B0604020202020204" pitchFamily="34" charset="0"/>
-              <a:buChar char="•"/>
-            </a:pPr>
-            <a:r>
-              <a:rPr lang="en-US" sz="2800" dirty="0">
-                <a:latin typeface="Arial" pitchFamily="34" charset="0"/>
-                <a:cs typeface="Arial" pitchFamily="34" charset="0"/>
-              </a:rPr>
-              <a:t> How it addresses the problem</a:t>
-            </a:r>
-          </a:p>
-          <a:p>
-            <a:pPr marL="342900" indent="-342900" algn="just">
-              <a:buFont typeface="Arial" panose="020B0604020202020204" pitchFamily="34" charset="0"/>
-              <a:buChar char="•"/>
-            </a:pPr>
-            <a:r>
-              <a:rPr lang="en-US" sz="2800" dirty="0">
-                <a:latin typeface="Arial" pitchFamily="34" charset="0"/>
-                <a:cs typeface="Arial" pitchFamily="34" charset="0"/>
-              </a:rPr>
-              <a:t>Innovation and uniqueness of the solution </a:t>
+            <a:pPr>
+              <a:spcBef>
+                <a:spcPts val="300"/>
+              </a:spcBef>
+              <a:spcAft>
+                <a:spcPts val="200"/>
+              </a:spcAft>
+            </a:pPr>
+            <a:r>
+              <a:rPr sz="1000" b="0">
+                <a:solidFill>
+                  <a:srgbClr val="333333"/>
+                </a:solidFill>
+              </a:rPr>
+              <a:t/>
+            </a:r>
+          </a:p>
+          <a:p>
+            <a:pPr>
+              <a:spcBef>
+                <a:spcPts val="800"/>
+              </a:spcBef>
+              <a:spcAft>
+                <a:spcPts val="200"/>
+              </a:spcAft>
+            </a:pPr>
+            <a:r>
+              <a:rPr sz="1100" b="1">
+                <a:solidFill>
+                  <a:srgbClr val="002147"/>
+                </a:solidFill>
+              </a:rPr>
+              <a:t>What It Is:</a:t>
+            </a:r>
+          </a:p>
+          <a:p>
+            <a:pPr>
+              <a:spcBef>
+                <a:spcPts val="300"/>
+              </a:spcBef>
+              <a:spcAft>
+                <a:spcPts val="200"/>
+              </a:spcAft>
+            </a:pPr>
+            <a:r>
+              <a:rPr sz="1000" b="0">
+                <a:solidFill>
+                  <a:srgbClr val="333333"/>
+                </a:solidFill>
+              </a:rPr>
+              <a:t>An AI-powered monitoring &amp; decision-support layer built on top of the existing eSAKSHI portal that analyzes 10,000+ MPLADS work records across 10 States &amp; 30 Districts using 11 independent AI signal engines.</a:t>
+            </a:r>
+          </a:p>
+          <a:p>
+            <a:pPr>
+              <a:spcBef>
+                <a:spcPts val="300"/>
+              </a:spcBef>
+              <a:spcAft>
+                <a:spcPts val="200"/>
+              </a:spcAft>
+            </a:pPr>
+            <a:r>
+              <a:rPr sz="1000" b="0">
+                <a:solidFill>
+                  <a:srgbClr val="333333"/>
+                </a:solidFill>
+              </a:rPr>
+              <a:t/>
+            </a:r>
+          </a:p>
+          <a:p>
+            <a:pPr>
+              <a:spcBef>
+                <a:spcPts val="800"/>
+              </a:spcBef>
+              <a:spcAft>
+                <a:spcPts val="200"/>
+              </a:spcAft>
+            </a:pPr>
+            <a:r>
+              <a:rPr sz="1100" b="1">
+                <a:solidFill>
+                  <a:srgbClr val="002147"/>
+                </a:solidFill>
+              </a:rPr>
+              <a:t>How It Addresses the Problem:</a:t>
+            </a:r>
+          </a:p>
+          <a:p>
+            <a:pPr>
+              <a:spcBef>
+                <a:spcPts val="300"/>
+              </a:spcBef>
+              <a:spcAft>
+                <a:spcPts val="200"/>
+              </a:spcAft>
+            </a:pPr>
+            <a:r>
+              <a:rPr sz="1000" b="0">
+                <a:solidFill>
+                  <a:srgbClr val="333333"/>
+                </a:solidFill>
+              </a:rPr>
+              <a:t>• Multi-Signal Risk Engine computes a composite Risk Score (0-100) from 11 weighted AI signals — combining Rule-Based Compliance, ML Statistical Outlier Detection (Isolation Forest), NLP Duplicate Detection, GIS Spatial Proximity, Payment vs Progress Gap Analysis, Cost Intelligence, Network Anomaly, Time Anomaly, and Predictive AI.</a:t>
+            </a:r>
+          </a:p>
+          <a:p>
+            <a:pPr>
+              <a:spcBef>
+                <a:spcPts val="300"/>
+              </a:spcBef>
+              <a:spcAft>
+                <a:spcPts val="200"/>
+              </a:spcAft>
+            </a:pPr>
+            <a:r>
+              <a:rPr sz="1000" b="0">
+                <a:solidFill>
+                  <a:srgbClr val="333333"/>
+                </a:solidFill>
+              </a:rPr>
+              <a:t>• Every flagged alert includes a structured "Why This Score?" explanation with per-signal contribution breakdown — enabling officers to prioritize field verification.</a:t>
+            </a:r>
+          </a:p>
+          <a:p>
+            <a:pPr>
+              <a:spcBef>
+                <a:spcPts val="300"/>
+              </a:spcBef>
+              <a:spcAft>
+                <a:spcPts val="200"/>
+              </a:spcAft>
+            </a:pPr>
+            <a:r>
+              <a:rPr sz="1000" b="0">
+                <a:solidFill>
+                  <a:srgbClr val="333333"/>
+                </a:solidFill>
+              </a:rPr>
+              <a:t>• National Risk Map classifies districts into Green/Yellow/Red risk zones for audit resource allocation.</a:t>
+            </a:r>
+          </a:p>
+          <a:p>
+            <a:pPr>
+              <a:spcBef>
+                <a:spcPts val="300"/>
+              </a:spcBef>
+              <a:spcAft>
+                <a:spcPts val="200"/>
+              </a:spcAft>
+            </a:pPr>
+            <a:r>
+              <a:rPr sz="1000" b="0">
+                <a:solidFill>
+                  <a:srgbClr val="333333"/>
+                </a:solidFill>
+              </a:rPr>
+              <a:t/>
+            </a:r>
+          </a:p>
+          <a:p>
+            <a:pPr>
+              <a:spcBef>
+                <a:spcPts val="800"/>
+              </a:spcBef>
+              <a:spcAft>
+                <a:spcPts val="200"/>
+              </a:spcAft>
+            </a:pPr>
+            <a:r>
+              <a:rPr sz="1100" b="1">
+                <a:solidFill>
+                  <a:srgbClr val="002147"/>
+                </a:solidFill>
+              </a:rPr>
+              <a:t>Innovation &amp; Uniqueness:</a:t>
+            </a:r>
+          </a:p>
+          <a:p>
+            <a:pPr>
+              <a:spcBef>
+                <a:spcPts val="300"/>
+              </a:spcBef>
+              <a:spcAft>
+                <a:spcPts val="200"/>
+              </a:spcAft>
+            </a:pPr>
+            <a:r>
+              <a:rPr sz="1000" b="0">
+                <a:solidFill>
+                  <a:srgbClr val="333333"/>
+                </a:solidFill>
+              </a:rPr>
+              <a:t>• GIS Spiral Intelligence — detects when same project types are repeatedly sanctioned in the same area (fund-cycling indicator).</a:t>
+            </a:r>
+          </a:p>
+          <a:p>
+            <a:pPr>
+              <a:spcBef>
+                <a:spcPts val="300"/>
+              </a:spcBef>
+              <a:spcAft>
+                <a:spcPts val="200"/>
+              </a:spcAft>
+            </a:pPr>
+            <a:r>
+              <a:rPr sz="1000" b="0">
+                <a:solidFill>
+                  <a:srgbClr val="333333"/>
+                </a:solidFill>
+              </a:rPr>
+              <a:t>• Contractor Nexus Graph — network analysis detecting agency monopolies, concurrent overload, and shell agency patterns.</a:t>
+            </a:r>
+          </a:p>
+          <a:p>
+            <a:pPr>
+              <a:spcBef>
+                <a:spcPts val="300"/>
+              </a:spcBef>
+              <a:spcAft>
+                <a:spcPts val="200"/>
+              </a:spcAft>
+            </a:pPr>
+            <a:r>
+              <a:rPr sz="1000" b="0">
+                <a:solidFill>
+                  <a:srgbClr val="333333"/>
+                </a:solidFill>
+              </a:rPr>
+              <a:t>• Construction Image Reuse Detection — perceptual hashing to detect identical photos submitted across different projects.</a:t>
+            </a:r>
+          </a:p>
+          <a:p>
+            <a:pPr>
+              <a:spcBef>
+                <a:spcPts val="300"/>
+              </a:spcBef>
+              <a:spcAft>
+                <a:spcPts val="200"/>
+              </a:spcAft>
+            </a:pPr>
+            <a:r>
+              <a:rPr sz="1000" b="0">
+                <a:solidFill>
+                  <a:srgbClr val="333333"/>
+                </a:solidFill>
+              </a:rPr>
+              <a:t>• Document Intelligence — verifies completeness of mandatory MPLADS paperwork at each lifecycle stage.</a:t>
+            </a:r>
+          </a:p>
+          <a:p>
+            <a:pPr>
+              <a:spcBef>
+                <a:spcPts val="300"/>
+              </a:spcBef>
+              <a:spcAft>
+                <a:spcPts val="200"/>
+              </a:spcAft>
+            </a:pPr>
+            <a:r>
+              <a:rPr sz="1000" b="0">
+                <a:solidFill>
+                  <a:srgbClr val="333333"/>
+                </a:solidFill>
+              </a:rPr>
+              <a:t>• The platform NEVER accuses — all findings are labeled "Potential Anomaly / Verification Required" with evidence confidence scores.</a:t>
             </a:r>
           </a:p>
         </p:txBody>
@@ -6323,8 +6402,13 @@
           <a:p>
             <a:pPr algn="ctr"/>
             <a:r>
-              <a:rPr lang="en-US" dirty="0"/>
-              <a:t>Your Team Name</a:t>
+              <a:rPr sz="900" b="1">
+                <a:solidFill>
+                  <a:srgbClr val="FFFFFF"/>
+                </a:solidFill>
+              </a:rPr>
+              <a:t>MPLADS
+RiskIntel</a:t>
             </a:r>
             <a:endParaRPr lang="en-IN" dirty="0"/>
           </a:p>
@@ -6511,24 +6595,282 @@
               <a:buChar char="•"/>
             </a:pPr>
             <a:r>
-              <a:rPr lang="en-US" sz="2800" dirty="0">
-                <a:latin typeface="Arial" pitchFamily="34" charset="0"/>
-                <a:cs typeface="Arial" pitchFamily="34" charset="0"/>
-              </a:rPr>
-              <a:t>Technologies to be used (e.g. programming languages, frameworks, hardware)</a:t>
-            </a:r>
-          </a:p>
-          <a:p>
-            <a:pPr marL="342900" indent="-342900" algn="just">
-              <a:buFont typeface="Arial" panose="020B0604020202020204" pitchFamily="34" charset="0"/>
-              <a:buChar char="•"/>
-            </a:pPr>
-            <a:r>
-              <a:rPr lang="en-US" sz="2800" dirty="0">
-                <a:latin typeface="Arial" pitchFamily="34" charset="0"/>
-                <a:cs typeface="Arial" pitchFamily="34" charset="0"/>
-              </a:rPr>
-              <a:t>Methodology and process for implementation (Flow Charts/Images/ working prototype)</a:t>
+              <a:rPr sz="1000" b="1">
+                <a:solidFill>
+                  <a:srgbClr val="002147"/>
+                </a:solidFill>
+              </a:rPr>
+              <a:t>Technologies Used:</a:t>
+            </a:r>
+          </a:p>
+          <a:p>
+            <a:pPr>
+              <a:spcBef>
+                <a:spcPts val="300"/>
+              </a:spcBef>
+              <a:spcAft>
+                <a:spcPts val="200"/>
+              </a:spcAft>
+            </a:pPr>
+            <a:r>
+              <a:rPr sz="900" b="0">
+                <a:solidFill>
+                  <a:srgbClr val="333333"/>
+                </a:solidFill>
+              </a:rPr>
+              <a:t>• Backend: Python 3.10+, FastAPI (REST API), Pydantic (schemas &amp; validation)</a:t>
+            </a:r>
+          </a:p>
+          <a:p>
+            <a:pPr>
+              <a:spcBef>
+                <a:spcPts val="300"/>
+              </a:spcBef>
+              <a:spcAft>
+                <a:spcPts val="200"/>
+              </a:spcAft>
+            </a:pPr>
+            <a:r>
+              <a:rPr sz="900" b="0">
+                <a:solidFill>
+                  <a:srgbClr val="333333"/>
+                </a:solidFill>
+              </a:rPr>
+              <a:t>• AI/ML: Scikit-Learn (Isolation Forest, LOF, Random Forest), Sentence-Transformers (semantic embeddings), TF-IDF + Cosine Similarity, Perceptual Hashing (pHash) for image analysis</a:t>
+            </a:r>
+          </a:p>
+          <a:p>
+            <a:pPr>
+              <a:spcBef>
+                <a:spcPts val="300"/>
+              </a:spcBef>
+              <a:spcAft>
+                <a:spcPts val="200"/>
+              </a:spcAft>
+            </a:pPr>
+            <a:r>
+              <a:rPr sz="900" b="0">
+                <a:solidFill>
+                  <a:srgbClr val="333333"/>
+                </a:solidFill>
+              </a:rPr>
+              <a:t>• Geospatial: Haversine Distance, GeoJSON boundaries, Leaflet.js (interactive maps)</a:t>
+            </a:r>
+          </a:p>
+          <a:p>
+            <a:pPr>
+              <a:spcBef>
+                <a:spcPts val="300"/>
+              </a:spcBef>
+              <a:spcAft>
+                <a:spcPts val="200"/>
+              </a:spcAft>
+            </a:pPr>
+            <a:r>
+              <a:rPr sz="900" b="0">
+                <a:solidFill>
+                  <a:srgbClr val="333333"/>
+                </a:solidFill>
+              </a:rPr>
+              <a:t>• Frontend: React 18 + Vite, Vanilla CSS (government design system), Lucide Icons, Chart.js/Recharts, D3.js (network graph)</a:t>
+            </a:r>
+          </a:p>
+          <a:p>
+            <a:pPr>
+              <a:spcBef>
+                <a:spcPts val="300"/>
+              </a:spcBef>
+              <a:spcAft>
+                <a:spcPts val="200"/>
+              </a:spcAft>
+            </a:pPr>
+            <a:r>
+              <a:rPr sz="900" b="0">
+                <a:solidFill>
+                  <a:srgbClr val="333333"/>
+                </a:solidFill>
+              </a:rPr>
+              <a:t>• AI Copilot: Google Gemini API with local RAG fallback engine</a:t>
+            </a:r>
+          </a:p>
+          <a:p>
+            <a:pPr>
+              <a:spcBef>
+                <a:spcPts val="300"/>
+              </a:spcBef>
+              <a:spcAft>
+                <a:spcPts val="200"/>
+              </a:spcAft>
+            </a:pPr>
+            <a:r>
+              <a:rPr sz="900" b="0">
+                <a:solidFill>
+                  <a:srgbClr val="333333"/>
+                </a:solidFill>
+              </a:rPr>
+              <a:t>• Data: NumPy, Pandas, 10,000-record synthetic eSAKSHI-aligned dataset</a:t>
+            </a:r>
+          </a:p>
+          <a:p>
+            <a:pPr>
+              <a:spcBef>
+                <a:spcPts val="300"/>
+              </a:spcBef>
+              <a:spcAft>
+                <a:spcPts val="200"/>
+              </a:spcAft>
+            </a:pPr>
+            <a:r>
+              <a:rPr sz="900" b="0">
+                <a:solidFill>
+                  <a:srgbClr val="333333"/>
+                </a:solidFill>
+              </a:rPr>
+              <a:t/>
+            </a:r>
+          </a:p>
+          <a:p>
+            <a:pPr>
+              <a:spcBef>
+                <a:spcPts val="800"/>
+              </a:spcBef>
+              <a:spcAft>
+                <a:spcPts val="200"/>
+              </a:spcAft>
+            </a:pPr>
+            <a:r>
+              <a:rPr sz="1000" b="1">
+                <a:solidFill>
+                  <a:srgbClr val="002147"/>
+                </a:solidFill>
+              </a:rPr>
+              <a:t>Methodology &amp; Architecture (Multi-Signal Pipeline):</a:t>
+            </a:r>
+          </a:p>
+          <a:p>
+            <a:pPr>
+              <a:spcBef>
+                <a:spcPts val="300"/>
+              </a:spcBef>
+              <a:spcAft>
+                <a:spcPts val="200"/>
+              </a:spcAft>
+            </a:pPr>
+            <a:r>
+              <a:rPr sz="900" b="0">
+                <a:solidFill>
+                  <a:srgbClr val="333333"/>
+                </a:solidFill>
+              </a:rPr>
+              <a:t>① Data Ingestion → eSAKSHI CSV/JSON ingested &amp; validated by Data Quality Engine (scores 0-100%)</a:t>
+            </a:r>
+          </a:p>
+          <a:p>
+            <a:pPr>
+              <a:spcBef>
+                <a:spcPts val="300"/>
+              </a:spcBef>
+              <a:spcAft>
+                <a:spcPts val="200"/>
+              </a:spcAft>
+            </a:pPr>
+            <a:r>
+              <a:rPr sz="900" b="0">
+                <a:solidFill>
+                  <a:srgbClr val="333333"/>
+                </a:solidFill>
+              </a:rPr>
+              <a:t>② Feature Engineering → Cost deviation ratios, spending velocity, financial-physical gap, duration ratios extracted</a:t>
+            </a:r>
+          </a:p>
+          <a:p>
+            <a:pPr>
+              <a:spcBef>
+                <a:spcPts val="300"/>
+              </a:spcBef>
+              <a:spcAft>
+                <a:spcPts val="200"/>
+              </a:spcAft>
+            </a:pPr>
+            <a:r>
+              <a:rPr sz="900" b="0">
+                <a:solidFill>
+                  <a:srgbClr val="333333"/>
+                </a:solidFill>
+              </a:rPr>
+              <a:t>③ 11 Parallel AI Engines → Rule Engine (5 rules) | ML Anomaly (Isolation Forest) | NLP Duplicate (TF-IDF + Embeddings) | GIS Proximity (Haversine) | Agency Risk Profiler | Payment vs Progress | Cost Intelligence | Network Anomaly | Time Anomaly | GIS Spiral | Document Intelligence</a:t>
+            </a:r>
+          </a:p>
+          <a:p>
+            <a:pPr>
+              <a:spcBef>
+                <a:spcPts val="300"/>
+              </a:spcBef>
+              <a:spcAft>
+                <a:spcPts val="200"/>
+              </a:spcAft>
+            </a:pPr>
+            <a:r>
+              <a:rPr sz="900" b="0">
+                <a:solidFill>
+                  <a:srgbClr val="333333"/>
+                </a:solidFill>
+              </a:rPr>
+              <a:t>④ Central Risk Engine v2.0 → Weighted composite score: Risk = Σ(wᵢ × Sᵢ) for 11 signals → 0-100 score → Low/Medium/High/Critical classification</a:t>
+            </a:r>
+          </a:p>
+          <a:p>
+            <a:pPr>
+              <a:spcBef>
+                <a:spcPts val="300"/>
+              </a:spcBef>
+              <a:spcAft>
+                <a:spcPts val="200"/>
+              </a:spcAft>
+            </a:pPr>
+            <a:r>
+              <a:rPr sz="900" b="0">
+                <a:solidFill>
+                  <a:srgbClr val="333333"/>
+                </a:solidFill>
+              </a:rPr>
+              <a:t>⑤ Explainable Alert Generation → Natural language narrative with per-signal evidence breakdown</a:t>
+            </a:r>
+          </a:p>
+          <a:p>
+            <a:pPr>
+              <a:spcBef>
+                <a:spcPts val="300"/>
+              </a:spcBef>
+              <a:spcAft>
+                <a:spcPts val="200"/>
+              </a:spcAft>
+            </a:pPr>
+            <a:r>
+              <a:rPr sz="900" b="0">
+                <a:solidFill>
+                  <a:srgbClr val="333333"/>
+                </a:solidFill>
+              </a:rPr>
+              <a:t>⑥ Human-in-the-Loop → Officer review (Escalate/Verify/Dismiss) → Immutable audit trail</a:t>
+            </a:r>
+          </a:p>
+          <a:p>
+            <a:pPr>
+              <a:spcBef>
+                <a:spcPts val="300"/>
+              </a:spcBef>
+              <a:spcAft>
+                <a:spcPts val="200"/>
+              </a:spcAft>
+            </a:pPr>
+            <a:r>
+              <a:rPr sz="900" b="0">
+                <a:solidFill>
+                  <a:srgbClr val="333333"/>
+                </a:solidFill>
+              </a:rPr>
+              <a:t>⑦ Intelligence Layer → AI Copilot (Gemini + RAG) | National Risk Map (Green/Yellow/Red) | Predictive Completion Forecast</a:t>
             </a:r>
           </a:p>
         </p:txBody>
@@ -6648,8 +6990,13 @@
           <a:p>
             <a:pPr algn="ctr"/>
             <a:r>
-              <a:rPr lang="en-US" dirty="0"/>
-              <a:t>Your Team Name</a:t>
+              <a:rPr sz="900" b="1">
+                <a:solidFill>
+                  <a:srgbClr val="FFFFFF"/>
+                </a:solidFill>
+              </a:rPr>
+              <a:t>MPLADS
+RiskIntel</a:t>
             </a:r>
             <a:endParaRPr lang="en-IN" dirty="0"/>
           </a:p>
@@ -6864,14 +7211,12 @@
               <a:defRPr/>
             </a:pPr>
             <a:r>
-              <a:rPr lang="en-US" sz="2800" dirty="0">
-                <a:solidFill>
-                  <a:prstClr val="black"/>
-                </a:solidFill>
-                <a:latin typeface="Arial" pitchFamily="34" charset="0"/>
-                <a:cs typeface="Arial" pitchFamily="34" charset="0"/>
-              </a:rPr>
-              <a:t>Analysis of the feasibility of the idea</a:t>
+              <a:rPr sz="1000" b="1">
+                <a:solidFill>
+                  <a:srgbClr val="002147"/>
+                </a:solidFill>
+              </a:rPr>
+              <a:t>Feasibility Analysis:</a:t>
             </a:r>
             <a:endParaRPr kumimoji="0" lang="en-US" sz="2800" b="0" i="0" u="none" strike="noStrike" kern="1200" cap="none" spc="0" normalizeH="0" baseline="0" noProof="0" dirty="0">
               <a:ln>
@@ -6889,100 +7234,328 @@
             </a:endParaRPr>
           </a:p>
           <a:p>
-            <a:pPr marL="342900" marR="0" lvl="0" indent="-342900" algn="just" defTabSz="457200" rtl="0" eaLnBrk="1" fontAlgn="base" latinLnBrk="0" hangingPunct="1">
-              <a:lnSpc>
-                <a:spcPct val="100000"/>
-              </a:lnSpc>
-              <a:spcBef>
-                <a:spcPct val="0"/>
-              </a:spcBef>
-              <a:spcAft>
-                <a:spcPct val="0"/>
-              </a:spcAft>
-              <a:buClrTx/>
-              <a:buSzTx/>
-              <a:buFont typeface="Arial" panose="020B0604020202020204" pitchFamily="34" charset="0"/>
-              <a:buChar char="•"/>
-              <a:tabLst/>
-              <a:defRPr/>
-            </a:pPr>
-            <a:r>
-              <a:rPr lang="en-US" sz="2800" dirty="0">
-                <a:solidFill>
-                  <a:prstClr val="black"/>
-                </a:solidFill>
-                <a:latin typeface="Arial" pitchFamily="34" charset="0"/>
-                <a:cs typeface="Arial" pitchFamily="34" charset="0"/>
-              </a:rPr>
-              <a:t>Potential challenges and risks</a:t>
-            </a:r>
-          </a:p>
-          <a:p>
-            <a:pPr marL="342900" marR="0" lvl="0" indent="-342900" algn="just" defTabSz="457200" rtl="0" eaLnBrk="1" fontAlgn="base" latinLnBrk="0" hangingPunct="1">
-              <a:lnSpc>
-                <a:spcPct val="100000"/>
-              </a:lnSpc>
-              <a:spcBef>
-                <a:spcPct val="0"/>
-              </a:spcBef>
-              <a:spcAft>
-                <a:spcPct val="0"/>
-              </a:spcAft>
-              <a:buClrTx/>
-              <a:buSzTx/>
-              <a:buFont typeface="Arial" panose="020B0604020202020204" pitchFamily="34" charset="0"/>
-              <a:buChar char="•"/>
-              <a:tabLst/>
-              <a:defRPr/>
-            </a:pPr>
-            <a:r>
-              <a:rPr kumimoji="0" lang="en-US" sz="2800" b="0" i="0" u="none" strike="noStrike" kern="1200" cap="none" spc="0" normalizeH="0" baseline="0" noProof="0" dirty="0">
-                <a:ln>
-                  <a:noFill/>
-                </a:ln>
-                <a:solidFill>
-                  <a:prstClr val="black"/>
-                </a:solidFill>
-                <a:effectLst/>
-                <a:uLnTx/>
-                <a:uFillTx/>
-                <a:latin typeface="Arial" pitchFamily="34" charset="0"/>
-                <a:ea typeface="ＭＳ Ｐゴシック" pitchFamily="1" charset="-128"/>
-                <a:cs typeface="Arial" pitchFamily="34" charset="0"/>
-              </a:rPr>
-              <a:t>Strategies</a:t>
-            </a:r>
-            <a:r>
-              <a:rPr kumimoji="0" lang="en-US" sz="2800" b="0" i="0" u="none" strike="noStrike" kern="1200" cap="none" spc="0" normalizeH="0" noProof="0" dirty="0">
-                <a:ln>
-                  <a:noFill/>
-                </a:ln>
-                <a:solidFill>
-                  <a:prstClr val="black"/>
-                </a:solidFill>
-                <a:effectLst/>
-                <a:uLnTx/>
-                <a:uFillTx/>
-                <a:latin typeface="Arial" pitchFamily="34" charset="0"/>
-                <a:ea typeface="ＭＳ Ｐゴシック" pitchFamily="1" charset="-128"/>
-                <a:cs typeface="Arial" pitchFamily="34" charset="0"/>
-              </a:rPr>
-              <a:t> for overcoming these challenges</a:t>
-            </a:r>
-            <a:endParaRPr kumimoji="0" lang="en-US" sz="2800" b="0" i="0" u="none" strike="noStrike" kern="1200" cap="none" spc="0" normalizeH="0" baseline="0" noProof="0" dirty="0">
-              <a:ln>
-                <a:noFill/>
-              </a:ln>
-              <a:solidFill>
-                <a:prstClr val="black"/>
-              </a:solidFill>
-              <a:effectLst/>
-              <a:uLnTx/>
-              <a:uFillTx/>
-              <a:latin typeface="Arial" pitchFamily="34" charset="0"/>
-              <a:ea typeface="ＭＳ Ｐゴシック" pitchFamily="1" charset="-128"/>
-              <a:cs typeface="Arial" pitchFamily="34" charset="0"/>
-            </a:endParaRPr>
+            <a:pPr>
+              <a:spcBef>
+                <a:spcPts val="300"/>
+              </a:spcBef>
+              <a:spcAft>
+                <a:spcPts val="200"/>
+              </a:spcAft>
+            </a:pPr>
+            <a:r>
+              <a:rPr sz="900" b="0">
+                <a:solidFill>
+                  <a:srgbClr val="333333"/>
+                </a:solidFill>
+              </a:rPr>
+              <a:t>• Built entirely on open-source, production-ready technologies (Python, FastAPI, React, Scikit-Learn) — no proprietary dependencies.</a:t>
+            </a:r>
+          </a:p>
+          <a:p>
+            <a:pPr>
+              <a:spcBef>
+                <a:spcPts val="300"/>
+              </a:spcBef>
+              <a:spcAft>
+                <a:spcPts val="200"/>
+              </a:spcAft>
+            </a:pPr>
+            <a:r>
+              <a:rPr sz="900" b="0">
+                <a:solidFill>
+                  <a:srgbClr val="333333"/>
+                </a:solidFill>
+              </a:rPr>
+              <a:t>• Data-aligned with real eSAKSHI portal structure — synthetic dataset mirrors actual MPLADS data fields (work_id, state, district, constituency, MP name, sanction amounts, progress percentages, GPS coordinates).</a:t>
+            </a:r>
+          </a:p>
+          <a:p>
+            <a:pPr>
+              <a:spcBef>
+                <a:spcPts val="300"/>
+              </a:spcBef>
+              <a:spcAft>
+                <a:spcPts val="200"/>
+              </a:spcAft>
+            </a:pPr>
+            <a:r>
+              <a:rPr sz="900" b="0">
+                <a:solidFill>
+                  <a:srgbClr val="333333"/>
+                </a:solidFill>
+              </a:rPr>
+              <a:t>• Operates as a decision-support overlay — does NOT replace or interfere with existing government systems.</a:t>
+            </a:r>
+          </a:p>
+          <a:p>
+            <a:pPr>
+              <a:spcBef>
+                <a:spcPts val="300"/>
+              </a:spcBef>
+              <a:spcAft>
+                <a:spcPts val="200"/>
+              </a:spcAft>
+            </a:pPr>
+            <a:r>
+              <a:rPr sz="900" b="0">
+                <a:solidFill>
+                  <a:srgbClr val="333333"/>
+                </a:solidFill>
+              </a:rPr>
+              <a:t>• Empirically validated: Precision 76.07%, Recall 48.37%, F1 Score 59.14% on labeled ground-truth anomaly test set.</a:t>
+            </a:r>
+          </a:p>
+          <a:p>
+            <a:pPr>
+              <a:spcBef>
+                <a:spcPts val="300"/>
+              </a:spcBef>
+              <a:spcAft>
+                <a:spcPts val="200"/>
+              </a:spcAft>
+            </a:pPr>
+            <a:r>
+              <a:rPr sz="900" b="0">
+                <a:solidFill>
+                  <a:srgbClr val="333333"/>
+                </a:solidFill>
+              </a:rPr>
+              <a:t>• Lightweight deployment — runs on standard cloud VMs, no GPU required for core ML pipeline.</a:t>
+            </a:r>
+          </a:p>
+          <a:p>
+            <a:pPr>
+              <a:spcBef>
+                <a:spcPts val="300"/>
+              </a:spcBef>
+              <a:spcAft>
+                <a:spcPts val="200"/>
+              </a:spcAft>
+            </a:pPr>
+            <a:r>
+              <a:rPr sz="900" b="0">
+                <a:solidFill>
+                  <a:srgbClr val="333333"/>
+                </a:solidFill>
+              </a:rPr>
+              <a:t/>
+            </a:r>
+          </a:p>
+          <a:p>
+            <a:pPr>
+              <a:spcBef>
+                <a:spcPts val="800"/>
+              </a:spcBef>
+              <a:spcAft>
+                <a:spcPts val="200"/>
+              </a:spcAft>
+            </a:pPr>
+            <a:r>
+              <a:rPr sz="1000" b="1">
+                <a:solidFill>
+                  <a:srgbClr val="002147"/>
+                </a:solidFill>
+              </a:rPr>
+              <a:t>Potential Challenges &amp; Risks:</a:t>
+            </a:r>
+          </a:p>
+          <a:p>
+            <a:pPr>
+              <a:spcBef>
+                <a:spcPts val="300"/>
+              </a:spcBef>
+              <a:spcAft>
+                <a:spcPts val="200"/>
+              </a:spcAft>
+            </a:pPr>
+            <a:r>
+              <a:rPr sz="900" b="0">
+                <a:solidFill>
+                  <a:srgbClr val="333333"/>
+                </a:solidFill>
+              </a:rPr>
+              <a:t>• Real-world eSAKSHI data access requires government authorization (no public API exists).</a:t>
+            </a:r>
+          </a:p>
+          <a:p>
+            <a:pPr>
+              <a:spcBef>
+                <a:spcPts val="300"/>
+              </a:spcBef>
+              <a:spcAft>
+                <a:spcPts val="200"/>
+              </a:spcAft>
+            </a:pPr>
+            <a:r>
+              <a:rPr sz="900" b="0">
+                <a:solidFill>
+                  <a:srgbClr val="333333"/>
+                </a:solidFill>
+              </a:rPr>
+              <a:t>• Image analysis (construction photos) requires consistent geo-tagged photo uploads by implementing agencies.</a:t>
+            </a:r>
+          </a:p>
+          <a:p>
+            <a:pPr>
+              <a:spcBef>
+                <a:spcPts val="300"/>
+              </a:spcBef>
+              <a:spcAft>
+                <a:spcPts val="200"/>
+              </a:spcAft>
+            </a:pPr>
+            <a:r>
+              <a:rPr sz="900" b="0">
+                <a:solidFill>
+                  <a:srgbClr val="333333"/>
+                </a:solidFill>
+              </a:rPr>
+              <a:t>• False positive management — some legitimate works may trigger anomaly signals.</a:t>
+            </a:r>
+          </a:p>
+          <a:p>
+            <a:pPr>
+              <a:spcBef>
+                <a:spcPts val="300"/>
+              </a:spcBef>
+              <a:spcAft>
+                <a:spcPts val="200"/>
+              </a:spcAft>
+            </a:pPr>
+            <a:r>
+              <a:rPr sz="900" b="0">
+                <a:solidFill>
+                  <a:srgbClr val="333333"/>
+                </a:solidFill>
+              </a:rPr>
+              <a:t>• Data quality varies across states — incomplete records reduce Evidence Confidence Score.</a:t>
+            </a:r>
+          </a:p>
+          <a:p>
+            <a:pPr>
+              <a:spcBef>
+                <a:spcPts val="300"/>
+              </a:spcBef>
+              <a:spcAft>
+                <a:spcPts val="200"/>
+              </a:spcAft>
+            </a:pPr>
+            <a:r>
+              <a:rPr sz="900" b="0">
+                <a:solidFill>
+                  <a:srgbClr val="333333"/>
+                </a:solidFill>
+              </a:rPr>
+              <a:t/>
+            </a:r>
+          </a:p>
+          <a:p>
+            <a:pPr>
+              <a:spcBef>
+                <a:spcPts val="800"/>
+              </a:spcBef>
+              <a:spcAft>
+                <a:spcPts val="200"/>
+              </a:spcAft>
+            </a:pPr>
+            <a:r>
+              <a:rPr sz="1000" b="1">
+                <a:solidFill>
+                  <a:srgbClr val="002147"/>
+                </a:solidFill>
+              </a:rPr>
+              <a:t>Strategies for Overcoming Challenges:</a:t>
+            </a:r>
+          </a:p>
+          <a:p>
+            <a:pPr>
+              <a:spcBef>
+                <a:spcPts val="300"/>
+              </a:spcBef>
+              <a:spcAft>
+                <a:spcPts val="200"/>
+              </a:spcAft>
+            </a:pPr>
+            <a:r>
+              <a:rPr sz="900" b="0">
+                <a:solidFill>
+                  <a:srgbClr val="333333"/>
+                </a:solidFill>
+              </a:rPr>
+              <a:t>• Evidence Confidence Score (0-100%) explicitly communicates data reliability to officers before action.</a:t>
+            </a:r>
+          </a:p>
+          <a:p>
+            <a:pPr>
+              <a:spcBef>
+                <a:spcPts val="300"/>
+              </a:spcBef>
+              <a:spcAft>
+                <a:spcPts val="200"/>
+              </a:spcAft>
+            </a:pPr>
+            <a:r>
+              <a:rPr sz="900" b="0">
+                <a:solidFill>
+                  <a:srgbClr val="333333"/>
+                </a:solidFill>
+              </a:rPr>
+              <a:t>• All alerts labeled "Verification Required" — never "Fraud" — preventing automated false accusations.</a:t>
+            </a:r>
+          </a:p>
+          <a:p>
+            <a:pPr>
+              <a:spcBef>
+                <a:spcPts val="300"/>
+              </a:spcBef>
+              <a:spcAft>
+                <a:spcPts val="200"/>
+              </a:spcAft>
+            </a:pPr>
+            <a:r>
+              <a:rPr sz="900" b="0">
+                <a:solidFill>
+                  <a:srgbClr val="333333"/>
+                </a:solidFill>
+              </a:rPr>
+              <a:t>• Configurable risk weights allow administrators to tune sensitivity per state/category.</a:t>
+            </a:r>
+          </a:p>
+          <a:p>
+            <a:pPr>
+              <a:spcBef>
+                <a:spcPts val="300"/>
+              </a:spcBef>
+              <a:spcAft>
+                <a:spcPts val="200"/>
+              </a:spcAft>
+            </a:pPr>
+            <a:r>
+              <a:rPr sz="900" b="0">
+                <a:solidFill>
+                  <a:srgbClr val="333333"/>
+                </a:solidFill>
+              </a:rPr>
+              <a:t>• Human-in-the-Loop workflow ensures no automated enforcement — officers retain full decision authority.</a:t>
+            </a:r>
+          </a:p>
+          <a:p>
+            <a:pPr>
+              <a:spcBef>
+                <a:spcPts val="300"/>
+              </a:spcBef>
+              <a:spcAft>
+                <a:spcPts val="200"/>
+              </a:spcAft>
+            </a:pPr>
+            <a:r>
+              <a:rPr sz="900" b="0">
+                <a:solidFill>
+                  <a:srgbClr val="333333"/>
+                </a:solidFill>
+              </a:rPr>
+              <a:t>• Data Quality Engine flags unreliable records (Invalid/Warning/Reliable) before analysis.</a:t>
+            </a:r>
           </a:p>
         </p:txBody>
       </p:sp>
@@ -7184,8 +7757,13 @@
           <a:p>
             <a:pPr algn="ctr"/>
             <a:r>
-              <a:rPr lang="en-US" dirty="0"/>
-              <a:t>Your Team Name</a:t>
+              <a:rPr sz="900" b="1">
+                <a:solidFill>
+                  <a:srgbClr val="FFFFFF"/>
+                </a:solidFill>
+              </a:rPr>
+              <a:t>MPLADS
+RiskIntel</a:t>
             </a:r>
             <a:endParaRPr lang="en-IN" dirty="0"/>
           </a:p>
@@ -7405,50 +7983,372 @@
               <a:defRPr/>
             </a:pPr>
             <a:r>
-              <a:rPr kumimoji="0" lang="en-US" sz="2800" b="0" i="0" u="none" strike="noStrike" kern="1200" cap="none" spc="0" normalizeH="0" baseline="0" noProof="0" dirty="0">
-                <a:ln>
-                  <a:noFill/>
-                </a:ln>
-                <a:solidFill>
-                  <a:prstClr val="black"/>
-                </a:solidFill>
-                <a:effectLst/>
-                <a:uLnTx/>
-                <a:uFillTx/>
-                <a:latin typeface="Arial" pitchFamily="34" charset="0"/>
-                <a:ea typeface="ＭＳ Ｐゴシック" pitchFamily="1" charset="-128"/>
-                <a:cs typeface="Arial" pitchFamily="34" charset="0"/>
-              </a:rPr>
-              <a:t>Potential impact on the target audience</a:t>
-            </a:r>
-          </a:p>
-          <a:p>
-            <a:pPr marL="342900" marR="0" lvl="0" indent="-342900" algn="just" defTabSz="457200" rtl="0" eaLnBrk="1" fontAlgn="base" latinLnBrk="0" hangingPunct="1">
-              <a:lnSpc>
-                <a:spcPct val="100000"/>
-              </a:lnSpc>
-              <a:spcBef>
-                <a:spcPct val="0"/>
-              </a:spcBef>
-              <a:spcAft>
-                <a:spcPct val="0"/>
-              </a:spcAft>
-              <a:buClrTx/>
-              <a:buSzTx/>
-              <a:buFont typeface="Arial" panose="020B0604020202020204" pitchFamily="34" charset="0"/>
-              <a:buChar char="•"/>
-              <a:tabLst/>
-              <a:defRPr/>
-            </a:pPr>
-            <a:r>
-              <a:rPr lang="en-US" sz="2800" dirty="0">
-                <a:solidFill>
-                  <a:prstClr val="black"/>
-                </a:solidFill>
-                <a:latin typeface="Arial" pitchFamily="34" charset="0"/>
-                <a:cs typeface="Arial" pitchFamily="34" charset="0"/>
-              </a:rPr>
-              <a:t>Benefits of the solution (social, economic, environmental, etc.)</a:t>
+              <a:rPr sz="1000" b="1">
+                <a:solidFill>
+                  <a:srgbClr val="002147"/>
+                </a:solidFill>
+              </a:rPr>
+              <a:t>Potential Impact on Target Audience:</a:t>
+            </a:r>
+          </a:p>
+          <a:p>
+            <a:pPr>
+              <a:spcBef>
+                <a:spcPts val="300"/>
+              </a:spcBef>
+              <a:spcAft>
+                <a:spcPts val="200"/>
+              </a:spcAft>
+            </a:pPr>
+            <a:r>
+              <a:rPr sz="900" b="0">
+                <a:solidFill>
+                  <a:srgbClr val="333333"/>
+                </a:solidFill>
+              </a:rPr>
+              <a:t>• Ministry of Statistics (MoSPI): Real-time national risk dashboard replacing manual audit selection — enables data-driven allocation of field inspection teams to highest-risk districts first.</a:t>
+            </a:r>
+          </a:p>
+          <a:p>
+            <a:pPr>
+              <a:spcBef>
+                <a:spcPts val="300"/>
+              </a:spcBef>
+              <a:spcAft>
+                <a:spcPts val="200"/>
+              </a:spcAft>
+            </a:pPr>
+            <a:r>
+              <a:rPr sz="900" b="0">
+                <a:solidFill>
+                  <a:srgbClr val="333333"/>
+                </a:solidFill>
+              </a:rPr>
+              <a:t>• District Collectors: Investigation dossiers with structured evidence reduce manual audit preparation time by estimated 60-70%.</a:t>
+            </a:r>
+          </a:p>
+          <a:p>
+            <a:pPr>
+              <a:spcBef>
+                <a:spcPts val="300"/>
+              </a:spcBef>
+              <a:spcAft>
+                <a:spcPts val="200"/>
+              </a:spcAft>
+            </a:pPr>
+            <a:r>
+              <a:rPr sz="900" b="0">
+                <a:solidFill>
+                  <a:srgbClr val="333333"/>
+                </a:solidFill>
+              </a:rPr>
+              <a:t>• Members of Parliament: Transparent tracking of constituency work progress, cost efficiency, and agency performance.</a:t>
+            </a:r>
+          </a:p>
+          <a:p>
+            <a:pPr>
+              <a:spcBef>
+                <a:spcPts val="300"/>
+              </a:spcBef>
+              <a:spcAft>
+                <a:spcPts val="200"/>
+              </a:spcAft>
+            </a:pPr>
+            <a:r>
+              <a:rPr sz="900" b="0">
+                <a:solidFill>
+                  <a:srgbClr val="333333"/>
+                </a:solidFill>
+              </a:rPr>
+              <a:t>• Citizens: Public request portal enables direct infrastructure grievance submission, increasing accountability.</a:t>
+            </a:r>
+          </a:p>
+          <a:p>
+            <a:pPr>
+              <a:spcBef>
+                <a:spcPts val="300"/>
+              </a:spcBef>
+              <a:spcAft>
+                <a:spcPts val="200"/>
+              </a:spcAft>
+            </a:pPr>
+            <a:r>
+              <a:rPr sz="900" b="0">
+                <a:solidFill>
+                  <a:srgbClr val="333333"/>
+                </a:solidFill>
+              </a:rPr>
+              <a:t>• Implementing Agencies: Performance scoring incentivizes timely completion and cost efficiency.</a:t>
+            </a:r>
+          </a:p>
+          <a:p>
+            <a:pPr>
+              <a:spcBef>
+                <a:spcPts val="300"/>
+              </a:spcBef>
+              <a:spcAft>
+                <a:spcPts val="200"/>
+              </a:spcAft>
+            </a:pPr>
+            <a:r>
+              <a:rPr sz="900" b="0">
+                <a:solidFill>
+                  <a:srgbClr val="333333"/>
+                </a:solidFill>
+              </a:rPr>
+              <a:t/>
+            </a:r>
+          </a:p>
+          <a:p>
+            <a:pPr>
+              <a:spcBef>
+                <a:spcPts val="800"/>
+              </a:spcBef>
+              <a:spcAft>
+                <a:spcPts val="200"/>
+              </a:spcAft>
+            </a:pPr>
+            <a:r>
+              <a:rPr sz="1000" b="1">
+                <a:solidFill>
+                  <a:srgbClr val="002147"/>
+                </a:solidFill>
+              </a:rPr>
+              <a:t>Social Benefits:</a:t>
+            </a:r>
+          </a:p>
+          <a:p>
+            <a:pPr>
+              <a:spcBef>
+                <a:spcPts val="300"/>
+              </a:spcBef>
+              <a:spcAft>
+                <a:spcPts val="200"/>
+              </a:spcAft>
+            </a:pPr>
+            <a:r>
+              <a:rPr sz="900" b="0">
+                <a:solidFill>
+                  <a:srgbClr val="333333"/>
+                </a:solidFill>
+              </a:rPr>
+              <a:t>• Strengthens public trust in MPLADS fund utilization through transparent AI-backed oversight.</a:t>
+            </a:r>
+          </a:p>
+          <a:p>
+            <a:pPr>
+              <a:spcBef>
+                <a:spcPts val="300"/>
+              </a:spcBef>
+              <a:spcAft>
+                <a:spcPts val="200"/>
+              </a:spcAft>
+            </a:pPr>
+            <a:r>
+              <a:rPr sz="900" b="0">
+                <a:solidFill>
+                  <a:srgbClr val="333333"/>
+                </a:solidFill>
+              </a:rPr>
+              <a:t>• Citizen Request Portal democratizes access to government infrastructure monitoring.</a:t>
+            </a:r>
+          </a:p>
+          <a:p>
+            <a:pPr>
+              <a:spcBef>
+                <a:spcPts val="300"/>
+              </a:spcBef>
+              <a:spcAft>
+                <a:spcPts val="200"/>
+              </a:spcAft>
+            </a:pPr>
+            <a:r>
+              <a:rPr sz="900" b="0">
+                <a:solidFill>
+                  <a:srgbClr val="333333"/>
+                </a:solidFill>
+              </a:rPr>
+              <a:t>• Reduces scope for fund misutilization, ensuring ₹3,940+ Crore annual MPLADS allocation reaches intended beneficiaries.</a:t>
+            </a:r>
+          </a:p>
+          <a:p>
+            <a:pPr>
+              <a:spcBef>
+                <a:spcPts val="300"/>
+              </a:spcBef>
+              <a:spcAft>
+                <a:spcPts val="200"/>
+              </a:spcAft>
+            </a:pPr>
+            <a:r>
+              <a:rPr sz="900" b="0">
+                <a:solidFill>
+                  <a:srgbClr val="333333"/>
+                </a:solidFill>
+              </a:rPr>
+              <a:t/>
+            </a:r>
+          </a:p>
+          <a:p>
+            <a:pPr>
+              <a:spcBef>
+                <a:spcPts val="800"/>
+              </a:spcBef>
+              <a:spcAft>
+                <a:spcPts val="200"/>
+              </a:spcAft>
+            </a:pPr>
+            <a:r>
+              <a:rPr sz="1000" b="1">
+                <a:solidFill>
+                  <a:srgbClr val="002147"/>
+                </a:solidFill>
+              </a:rPr>
+              <a:t>Economic Benefits:</a:t>
+            </a:r>
+          </a:p>
+          <a:p>
+            <a:pPr>
+              <a:spcBef>
+                <a:spcPts val="300"/>
+              </a:spcBef>
+              <a:spcAft>
+                <a:spcPts val="200"/>
+              </a:spcAft>
+            </a:pPr>
+            <a:r>
+              <a:rPr sz="900" b="0">
+                <a:solidFill>
+                  <a:srgbClr val="333333"/>
+                </a:solidFill>
+              </a:rPr>
+              <a:t>• Cost Intelligence Engine detects inflated estimates &amp; cost-splitting — potential savings of 15-25% on flagged projects.</a:t>
+            </a:r>
+          </a:p>
+          <a:p>
+            <a:pPr>
+              <a:spcBef>
+                <a:spcPts val="300"/>
+              </a:spcBef>
+              <a:spcAft>
+                <a:spcPts val="200"/>
+              </a:spcAft>
+            </a:pPr>
+            <a:r>
+              <a:rPr sz="900" b="0">
+                <a:solidFill>
+                  <a:srgbClr val="333333"/>
+                </a:solidFill>
+              </a:rPr>
+              <a:t>• National Risk Map enables efficient audit resource deployment — reducing unnecessary field visits to low-risk zones.</a:t>
+            </a:r>
+          </a:p>
+          <a:p>
+            <a:pPr>
+              <a:spcBef>
+                <a:spcPts val="300"/>
+              </a:spcBef>
+              <a:spcAft>
+                <a:spcPts val="200"/>
+              </a:spcAft>
+            </a:pPr>
+            <a:r>
+              <a:rPr sz="900" b="0">
+                <a:solidFill>
+                  <a:srgbClr val="333333"/>
+                </a:solidFill>
+              </a:rPr>
+              <a:t>• Predictive AI forecasts project delays early — enabling proactive intervention before cost overruns materialize.</a:t>
+            </a:r>
+          </a:p>
+          <a:p>
+            <a:pPr>
+              <a:spcBef>
+                <a:spcPts val="300"/>
+              </a:spcBef>
+              <a:spcAft>
+                <a:spcPts val="200"/>
+              </a:spcAft>
+            </a:pPr>
+            <a:r>
+              <a:rPr sz="900" b="0">
+                <a:solidFill>
+                  <a:srgbClr val="333333"/>
+                </a:solidFill>
+              </a:rPr>
+              <a:t/>
+            </a:r>
+          </a:p>
+          <a:p>
+            <a:pPr>
+              <a:spcBef>
+                <a:spcPts val="800"/>
+              </a:spcBef>
+              <a:spcAft>
+                <a:spcPts val="200"/>
+              </a:spcAft>
+            </a:pPr>
+            <a:r>
+              <a:rPr sz="1000" b="1">
+                <a:solidFill>
+                  <a:srgbClr val="002147"/>
+                </a:solidFill>
+              </a:rPr>
+              <a:t>Governance &amp; Administrative Benefits:</a:t>
+            </a:r>
+          </a:p>
+          <a:p>
+            <a:pPr>
+              <a:spcBef>
+                <a:spcPts val="300"/>
+              </a:spcBef>
+              <a:spcAft>
+                <a:spcPts val="200"/>
+              </a:spcAft>
+            </a:pPr>
+            <a:r>
+              <a:rPr sz="900" b="0">
+                <a:solidFill>
+                  <a:srgbClr val="333333"/>
+                </a:solidFill>
+              </a:rPr>
+              <a:t>• Append-only audit trail provides immutable record of all officer actions for RTI/CAG compliance.</a:t>
+            </a:r>
+          </a:p>
+          <a:p>
+            <a:pPr>
+              <a:spcBef>
+                <a:spcPts val="300"/>
+              </a:spcBef>
+              <a:spcAft>
+                <a:spcPts val="200"/>
+              </a:spcAft>
+            </a:pPr>
+            <a:r>
+              <a:rPr sz="900" b="0">
+                <a:solidFill>
+                  <a:srgbClr val="333333"/>
+                </a:solidFill>
+              </a:rPr>
+              <a:t>• Network Anomaly detection identifies contractor cartels and agency monopolies before they cause systemic damage.</a:t>
+            </a:r>
+          </a:p>
+          <a:p>
+            <a:pPr>
+              <a:spcBef>
+                <a:spcPts val="300"/>
+              </a:spcBef>
+              <a:spcAft>
+                <a:spcPts val="200"/>
+              </a:spcAft>
+            </a:pPr>
+            <a:r>
+              <a:rPr sz="900" b="0">
+                <a:solidFill>
+                  <a:srgbClr val="333333"/>
+                </a:solidFill>
+              </a:rPr>
+              <a:t>• Document Intelligence ensures mandatory UC/NOC/Completion Certificate compliance, reducing paperwork gaps across 543 constituencies.</a:t>
             </a:r>
           </a:p>
         </p:txBody>
@@ -7651,8 +8551,13 @@
           <a:p>
             <a:pPr algn="ctr"/>
             <a:r>
-              <a:rPr lang="en-US" dirty="0"/>
-              <a:t>Your Team Name</a:t>
+              <a:rPr sz="900" b="1">
+                <a:solidFill>
+                  <a:srgbClr val="FFFFFF"/>
+                </a:solidFill>
+              </a:rPr>
+              <a:t>MPLADS
+RiskIntel</a:t>
             </a:r>
             <a:endParaRPr lang="en-IN" dirty="0"/>
           </a:p>
@@ -7872,14 +8777,12 @@
               <a:defRPr/>
             </a:pPr>
             <a:r>
-              <a:rPr lang="en-US" sz="2800" noProof="0" dirty="0">
-                <a:solidFill>
-                  <a:prstClr val="black"/>
-                </a:solidFill>
-                <a:latin typeface="Arial" pitchFamily="34" charset="0"/>
-                <a:cs typeface="Arial" pitchFamily="34" charset="0"/>
-              </a:rPr>
-              <a:t>Details / Links of the reference and research work</a:t>
+              <a:rPr sz="1100" b="1">
+                <a:solidFill>
+                  <a:srgbClr val="002147"/>
+                </a:solidFill>
+              </a:rPr>
+              <a:t>Primary Government Sources:</a:t>
             </a:r>
             <a:endParaRPr kumimoji="0" lang="en-US" sz="2800" b="0" i="0" u="none" strike="noStrike" kern="1200" cap="none" spc="0" normalizeH="0" baseline="0" noProof="0" dirty="0">
               <a:ln>
@@ -7895,6 +8798,294 @@
               <a:ea typeface="ＭＳ Ｐゴシック" pitchFamily="1" charset="-128"/>
               <a:cs typeface="Arial" pitchFamily="34" charset="0"/>
             </a:endParaRPr>
+          </a:p>
+          <a:p>
+            <a:pPr>
+              <a:spcBef>
+                <a:spcPts val="300"/>
+              </a:spcBef>
+              <a:spcAft>
+                <a:spcPts val="200"/>
+              </a:spcAft>
+            </a:pPr>
+            <a:r>
+              <a:rPr sz="1000" b="0">
+                <a:solidFill>
+                  <a:srgbClr val="333333"/>
+                </a:solidFill>
+              </a:rPr>
+              <a:t>• eSAKSHI Portal (Official MPLADS Digital Platform) — https://mplads.mospi.gov.in/</a:t>
+            </a:r>
+          </a:p>
+          <a:p>
+            <a:pPr>
+              <a:spcBef>
+                <a:spcPts val="300"/>
+              </a:spcBef>
+              <a:spcAft>
+                <a:spcPts val="200"/>
+              </a:spcAft>
+            </a:pPr>
+            <a:r>
+              <a:rPr sz="1000" b="0">
+                <a:solidFill>
+                  <a:srgbClr val="333333"/>
+                </a:solidFill>
+              </a:rPr>
+              <a:t>• MPLADS Guidelines (Revised 2016) — Ministry of Statistics &amp; Programme Implementation, Government of India</a:t>
+            </a:r>
+          </a:p>
+          <a:p>
+            <a:pPr>
+              <a:spcBef>
+                <a:spcPts val="300"/>
+              </a:spcBef>
+              <a:spcAft>
+                <a:spcPts val="200"/>
+              </a:spcAft>
+            </a:pPr>
+            <a:r>
+              <a:rPr sz="1000" b="0">
+                <a:solidFill>
+                  <a:srgbClr val="333333"/>
+                </a:solidFill>
+              </a:rPr>
+              <a:t>• CAG Audit Reports on MPLADS Fund Utilization (2018-2023) — Comptroller &amp; Auditor General of India</a:t>
+            </a:r>
+          </a:p>
+          <a:p>
+            <a:pPr>
+              <a:spcBef>
+                <a:spcPts val="300"/>
+              </a:spcBef>
+              <a:spcAft>
+                <a:spcPts val="200"/>
+              </a:spcAft>
+            </a:pPr>
+            <a:r>
+              <a:rPr sz="1000" b="0">
+                <a:solidFill>
+                  <a:srgbClr val="333333"/>
+                </a:solidFill>
+              </a:rPr>
+              <a:t>• Lok Sabha / Rajya Sabha MP Constituency Allocation Data — Official Parliamentary Records</a:t>
+            </a:r>
+          </a:p>
+          <a:p>
+            <a:pPr>
+              <a:spcBef>
+                <a:spcPts val="300"/>
+              </a:spcBef>
+              <a:spcAft>
+                <a:spcPts val="200"/>
+              </a:spcAft>
+            </a:pPr>
+            <a:r>
+              <a:rPr sz="1000" b="0">
+                <a:solidFill>
+                  <a:srgbClr val="333333"/>
+                </a:solidFill>
+              </a:rPr>
+              <a:t/>
+            </a:r>
+          </a:p>
+          <a:p>
+            <a:pPr>
+              <a:spcBef>
+                <a:spcPts val="800"/>
+              </a:spcBef>
+              <a:spcAft>
+                <a:spcPts val="200"/>
+              </a:spcAft>
+            </a:pPr>
+            <a:r>
+              <a:rPr sz="1100" b="1">
+                <a:solidFill>
+                  <a:srgbClr val="002147"/>
+                </a:solidFill>
+              </a:rPr>
+              <a:t>Technical &amp; ML Research References:</a:t>
+            </a:r>
+          </a:p>
+          <a:p>
+            <a:pPr>
+              <a:spcBef>
+                <a:spcPts val="300"/>
+              </a:spcBef>
+              <a:spcAft>
+                <a:spcPts val="200"/>
+              </a:spcAft>
+            </a:pPr>
+            <a:r>
+              <a:rPr sz="1000" b="0">
+                <a:solidFill>
+                  <a:srgbClr val="333333"/>
+                </a:solidFill>
+              </a:rPr>
+              <a:t>• F. T. Liu, K. M. Ting, Z. Zhou — "Isolation Forest" (IEEE ICDM 2008) — Foundation for unsupervised anomaly detection engine</a:t>
+            </a:r>
+          </a:p>
+          <a:p>
+            <a:pPr>
+              <a:spcBef>
+                <a:spcPts val="300"/>
+              </a:spcBef>
+              <a:spcAft>
+                <a:spcPts val="200"/>
+              </a:spcAft>
+            </a:pPr>
+            <a:r>
+              <a:rPr sz="1000" b="0">
+                <a:solidFill>
+                  <a:srgbClr val="333333"/>
+                </a:solidFill>
+              </a:rPr>
+              <a:t>• M. M. Breunig et al. — "LOF: Identifying Density-Based Local Outliers" (ACM SIGMOD 2000) — Local Outlier Factor methodology</a:t>
+            </a:r>
+          </a:p>
+          <a:p>
+            <a:pPr>
+              <a:spcBef>
+                <a:spcPts val="300"/>
+              </a:spcBef>
+              <a:spcAft>
+                <a:spcPts val="200"/>
+              </a:spcAft>
+            </a:pPr>
+            <a:r>
+              <a:rPr sz="1000" b="0">
+                <a:solidFill>
+                  <a:srgbClr val="333333"/>
+                </a:solidFill>
+              </a:rPr>
+              <a:t>• Sentence-BERT: Sentence Embeddings using Siamese BERT-Networks (Reimers &amp; Gurevych, 2019) — Semantic duplicate detection</a:t>
+            </a:r>
+          </a:p>
+          <a:p>
+            <a:pPr>
+              <a:spcBef>
+                <a:spcPts val="300"/>
+              </a:spcBef>
+              <a:spcAft>
+                <a:spcPts val="200"/>
+              </a:spcAft>
+            </a:pPr>
+            <a:r>
+              <a:rPr sz="1000" b="0">
+                <a:solidFill>
+                  <a:srgbClr val="333333"/>
+                </a:solidFill>
+              </a:rPr>
+              <a:t>• Perceptual Hashing — pHash algorithm for image fingerprinting &amp; cross-project reuse detection</a:t>
+            </a:r>
+          </a:p>
+          <a:p>
+            <a:pPr>
+              <a:spcBef>
+                <a:spcPts val="300"/>
+              </a:spcBef>
+              <a:spcAft>
+                <a:spcPts val="200"/>
+              </a:spcAft>
+            </a:pPr>
+            <a:r>
+              <a:rPr sz="1000" b="0">
+                <a:solidFill>
+                  <a:srgbClr val="333333"/>
+                </a:solidFill>
+              </a:rPr>
+              <a:t>• Haversine Formula — Great-circle distance for geospatial proximity and spiral pattern detection</a:t>
+            </a:r>
+          </a:p>
+          <a:p>
+            <a:pPr>
+              <a:spcBef>
+                <a:spcPts val="300"/>
+              </a:spcBef>
+              <a:spcAft>
+                <a:spcPts val="200"/>
+              </a:spcAft>
+            </a:pPr>
+            <a:r>
+              <a:rPr sz="1000" b="0">
+                <a:solidFill>
+                  <a:srgbClr val="333333"/>
+                </a:solidFill>
+              </a:rPr>
+              <a:t/>
+            </a:r>
+          </a:p>
+          <a:p>
+            <a:pPr>
+              <a:spcBef>
+                <a:spcPts val="800"/>
+              </a:spcBef>
+              <a:spcAft>
+                <a:spcPts val="200"/>
+              </a:spcAft>
+            </a:pPr>
+            <a:r>
+              <a:rPr sz="1100" b="1">
+                <a:solidFill>
+                  <a:srgbClr val="002147"/>
+                </a:solidFill>
+              </a:rPr>
+              <a:t>Data &amp; Domain References:</a:t>
+            </a:r>
+          </a:p>
+          <a:p>
+            <a:pPr>
+              <a:spcBef>
+                <a:spcPts val="300"/>
+              </a:spcBef>
+              <a:spcAft>
+                <a:spcPts val="200"/>
+              </a:spcAft>
+            </a:pPr>
+            <a:r>
+              <a:rPr sz="1000" b="0">
+                <a:solidFill>
+                  <a:srgbClr val="333333"/>
+                </a:solidFill>
+              </a:rPr>
+              <a:t>• Allocated Limit for Hon'ble MPs (Official Excel Database) — 543 Lok Sabha MP allocation records</a:t>
+            </a:r>
+          </a:p>
+          <a:p>
+            <a:pPr>
+              <a:spcBef>
+                <a:spcPts val="300"/>
+              </a:spcBef>
+              <a:spcAft>
+                <a:spcPts val="200"/>
+              </a:spcAft>
+            </a:pPr>
+            <a:r>
+              <a:rPr sz="1000" b="0">
+                <a:solidFill>
+                  <a:srgbClr val="333333"/>
+                </a:solidFill>
+              </a:rPr>
+              <a:t>• State-wise MPLADS expenditure and work completion statistics (eSAKSHI public dashboard data)</a:t>
+            </a:r>
+          </a:p>
+          <a:p>
+            <a:pPr>
+              <a:spcBef>
+                <a:spcPts val="300"/>
+              </a:spcBef>
+              <a:spcAft>
+                <a:spcPts val="200"/>
+              </a:spcAft>
+            </a:pPr>
+            <a:r>
+              <a:rPr sz="1000" b="0">
+                <a:solidFill>
+                  <a:srgbClr val="333333"/>
+                </a:solidFill>
+              </a:rPr>
+              <a:t>• GitHub Repository: https://github.com/sujoy18207/SIH2026</a:t>
+            </a:r>
           </a:p>
         </p:txBody>
       </p:sp>
@@ -8096,8 +9287,13 @@
           <a:p>
             <a:pPr algn="ctr"/>
             <a:r>
-              <a:rPr lang="en-US" dirty="0"/>
-              <a:t>Your Team Name</a:t>
+              <a:rPr sz="900" b="1">
+                <a:solidFill>
+                  <a:srgbClr val="FFFFFF"/>
+                </a:solidFill>
+              </a:rPr>
+              <a:t>MPLADS
+RiskIntel</a:t>
             </a:r>
             <a:endParaRPr lang="en-IN" dirty="0"/>
           </a:p>
@@ -8137,859 +9333,6 @@
     <p:extLst>
       <p:ext uri="{BB962C8B-B14F-4D97-AF65-F5344CB8AC3E}">
         <p14:creationId xmlns:p14="http://schemas.microsoft.com/office/powerpoint/2010/main" val="3916788613"/>
-      </p:ext>
-    </p:extLst>
-  </p:cSld>
-  <p:clrMapOvr>
-    <a:masterClrMapping/>
-  </p:clrMapOvr>
-</p:sld>
-</file>
-
-<file path=ppt/slides/slide7.xml><?xml version="1.0" encoding="utf-8"?>
-<p:sld xmlns:a="http://schemas.openxmlformats.org/drawingml/2006/main" xmlns:r="http://schemas.openxmlformats.org/officeDocument/2006/relationships" xmlns:p="http://schemas.openxmlformats.org/presentationml/2006/main">
-  <p:cSld>
-    <p:spTree>
-      <p:nvGrpSpPr>
-        <p:cNvPr id="1" name=""/>
-        <p:cNvGrpSpPr/>
-        <p:nvPr/>
-      </p:nvGrpSpPr>
-      <p:grpSpPr>
-        <a:xfrm>
-          <a:off x="0" y="0"/>
-          <a:ext cx="0" cy="0"/>
-          <a:chOff x="0" y="0"/>
-          <a:chExt cx="0" cy="0"/>
-        </a:xfrm>
-      </p:grpSpPr>
-      <p:sp>
-        <p:nvSpPr>
-          <p:cNvPr id="10" name="Rectangle 9">
-            <a:extLst>
-              <a:ext uri="{FF2B5EF4-FFF2-40B4-BE49-F238E27FC236}">
-                <a16:creationId xmlns:a16="http://schemas.microsoft.com/office/drawing/2014/main" id="{AD4F69D3-EEB0-4C4C-9434-B9960FB5854C}"/>
-              </a:ext>
-            </a:extLst>
-          </p:cNvPr>
-          <p:cNvSpPr>
-            <a:spLocks noChangeArrowheads="1"/>
-          </p:cNvSpPr>
-          <p:nvPr/>
-        </p:nvSpPr>
-        <p:spPr bwMode="auto">
-          <a:xfrm>
-            <a:off x="0" y="6354762"/>
-            <a:ext cx="12191999" cy="503238"/>
-          </a:xfrm>
-          <a:prstGeom prst="rect">
-            <a:avLst/>
-          </a:prstGeom>
-          <a:solidFill>
-            <a:srgbClr val="0070C0"/>
-          </a:solidFill>
-          <a:ln w="9525">
-            <a:noFill/>
-            <a:miter lim="800000"/>
-            <a:headEnd/>
-            <a:tailEnd/>
-          </a:ln>
-          <a:effectLst>
-            <a:outerShdw dist="23000" dir="5400000" rotWithShape="0">
-              <a:srgbClr val="808080">
-                <a:alpha val="34999"/>
-              </a:srgbClr>
-            </a:outerShdw>
-          </a:effectLst>
-        </p:spPr>
-        <p:txBody>
-          <a:bodyPr anchor="ctr"/>
-          <a:lstStyle/>
-          <a:p>
-            <a:pPr marL="0" marR="0" lvl="0" indent="0" algn="ctr" defTabSz="457200" rtl="0" eaLnBrk="1" fontAlgn="auto" latinLnBrk="0" hangingPunct="1">
-              <a:lnSpc>
-                <a:spcPct val="100000"/>
-              </a:lnSpc>
-              <a:spcBef>
-                <a:spcPts val="0"/>
-              </a:spcBef>
-              <a:spcAft>
-                <a:spcPts val="0"/>
-              </a:spcAft>
-              <a:buClrTx/>
-              <a:buSzTx/>
-              <a:buFontTx/>
-              <a:buNone/>
-              <a:tabLst/>
-              <a:defRPr/>
-            </a:pPr>
-            <a:endParaRPr kumimoji="0" lang="en-US" sz="1800" b="0" i="0" u="none" strike="noStrike" kern="1200" cap="none" spc="0" normalizeH="0" baseline="0" noProof="0" dirty="0">
-              <a:ln>
-                <a:noFill/>
-              </a:ln>
-              <a:solidFill>
-                <a:srgbClr val="C0504D">
-                  <a:lumMod val="75000"/>
-                </a:srgbClr>
-              </a:solidFill>
-              <a:effectLst/>
-              <a:uLnTx/>
-              <a:uFillTx/>
-              <a:latin typeface="Calibri"/>
-              <a:ea typeface="ＭＳ Ｐゴシック" pitchFamily="1" charset="-128"/>
-              <a:cs typeface="+mn-cs"/>
-            </a:endParaRPr>
-          </a:p>
-        </p:txBody>
-      </p:sp>
-      <p:sp>
-        <p:nvSpPr>
-          <p:cNvPr id="6" name="Slide Number Placeholder 5"/>
-          <p:cNvSpPr>
-            <a:spLocks noGrp="1"/>
-          </p:cNvSpPr>
-          <p:nvPr>
-            <p:ph type="sldNum" sz="quarter" idx="12"/>
-          </p:nvPr>
-        </p:nvSpPr>
-        <p:spPr/>
-        <p:txBody>
-          <a:bodyPr/>
-          <a:lstStyle/>
-          <a:p>
-            <a:pPr marL="0" marR="0" lvl="0" indent="0" algn="r" defTabSz="457200" rtl="0" eaLnBrk="1" fontAlgn="base" latinLnBrk="0" hangingPunct="1">
-              <a:lnSpc>
-                <a:spcPct val="100000"/>
-              </a:lnSpc>
-              <a:spcBef>
-                <a:spcPct val="0"/>
-              </a:spcBef>
-              <a:spcAft>
-                <a:spcPct val="0"/>
-              </a:spcAft>
-              <a:buClrTx/>
-              <a:buSzTx/>
-              <a:buFontTx/>
-              <a:buNone/>
-              <a:tabLst/>
-              <a:defRPr/>
-            </a:pPr>
-            <a:fld id="{677C3CE7-23F7-4828-823C-E0205DF2CF97}" type="slidenum">
-              <a:rPr kumimoji="0" lang="en-US" sz="1200" b="1" i="0" u="none" strike="noStrike" kern="1200" cap="none" spc="0" normalizeH="0" baseline="0" noProof="0">
-                <a:ln>
-                  <a:noFill/>
-                </a:ln>
-                <a:solidFill>
-                  <a:prstClr val="white"/>
-                </a:solidFill>
-                <a:effectLst/>
-                <a:uLnTx/>
-                <a:uFillTx/>
-                <a:latin typeface="TradeGothic" pitchFamily="1" charset="0"/>
-                <a:ea typeface="ＭＳ Ｐゴシック" pitchFamily="1" charset="-128"/>
-                <a:cs typeface="+mn-cs"/>
-              </a:rPr>
-              <a:pPr marL="0" marR="0" lvl="0" indent="0" algn="r" defTabSz="457200" rtl="0" eaLnBrk="1" fontAlgn="base" latinLnBrk="0" hangingPunct="1">
-                <a:lnSpc>
-                  <a:spcPct val="100000"/>
-                </a:lnSpc>
-                <a:spcBef>
-                  <a:spcPct val="0"/>
-                </a:spcBef>
-                <a:spcAft>
-                  <a:spcPct val="0"/>
-                </a:spcAft>
-                <a:buClrTx/>
-                <a:buSzTx/>
-                <a:buFontTx/>
-                <a:buNone/>
-                <a:tabLst/>
-                <a:defRPr/>
-              </a:pPr>
-              <a:t>7</a:t>
-            </a:fld>
-            <a:endParaRPr kumimoji="0" lang="en-US" sz="1200" b="1" i="0" u="none" strike="noStrike" kern="1200" cap="none" spc="0" normalizeH="0" baseline="0" noProof="0" dirty="0">
-              <a:ln>
-                <a:noFill/>
-              </a:ln>
-              <a:solidFill>
-                <a:prstClr val="white"/>
-              </a:solidFill>
-              <a:effectLst/>
-              <a:uLnTx/>
-              <a:uFillTx/>
-              <a:latin typeface="TradeGothic" pitchFamily="1" charset="0"/>
-              <a:ea typeface="ＭＳ Ｐゴシック" pitchFamily="1" charset="-128"/>
-              <a:cs typeface="+mn-cs"/>
-            </a:endParaRPr>
-          </a:p>
-        </p:txBody>
-      </p:sp>
-      <p:sp>
-        <p:nvSpPr>
-          <p:cNvPr id="7" name="Footer Placeholder 6"/>
-          <p:cNvSpPr>
-            <a:spLocks noGrp="1"/>
-          </p:cNvSpPr>
-          <p:nvPr>
-            <p:ph type="ftr" sz="quarter" idx="11"/>
-          </p:nvPr>
-        </p:nvSpPr>
-        <p:spPr>
-          <a:xfrm>
-            <a:off x="4648200" y="6356353"/>
-            <a:ext cx="3204000" cy="365125"/>
-          </a:xfrm>
-        </p:spPr>
-        <p:txBody>
-          <a:bodyPr/>
-          <a:lstStyle/>
-          <a:p>
-            <a:pPr marL="0" marR="0" lvl="0" indent="0" algn="ctr" defTabSz="457200" rtl="0" eaLnBrk="1" fontAlgn="auto" latinLnBrk="0" hangingPunct="1">
-              <a:lnSpc>
-                <a:spcPct val="100000"/>
-              </a:lnSpc>
-              <a:spcBef>
-                <a:spcPts val="0"/>
-              </a:spcBef>
-              <a:spcAft>
-                <a:spcPts val="0"/>
-              </a:spcAft>
-              <a:buClrTx/>
-              <a:buSzTx/>
-              <a:buFontTx/>
-              <a:buNone/>
-              <a:tabLst/>
-              <a:defRPr/>
-            </a:pPr>
-            <a:r>
-              <a:rPr kumimoji="0" lang="en-US" sz="1200" b="0" i="0" u="none" strike="noStrike" kern="1200" cap="none" spc="0" normalizeH="0" baseline="0" noProof="0">
-                <a:ln>
-                  <a:noFill/>
-                </a:ln>
-                <a:solidFill>
-                  <a:prstClr val="white"/>
-                </a:solidFill>
-                <a:effectLst/>
-                <a:uLnTx/>
-                <a:uFillTx/>
-                <a:latin typeface="TradeGothic"/>
-                <a:ea typeface="+mn-ea"/>
-                <a:cs typeface="+mn-cs"/>
-              </a:rPr>
-              <a:t>@SIH Idea submission- Template</a:t>
-            </a:r>
-            <a:endParaRPr kumimoji="0" lang="en-US" sz="1200" b="0" i="0" u="none" strike="noStrike" kern="1200" cap="none" spc="0" normalizeH="0" baseline="0" noProof="0" dirty="0">
-              <a:ln>
-                <a:noFill/>
-              </a:ln>
-              <a:solidFill>
-                <a:prstClr val="white"/>
-              </a:solidFill>
-              <a:effectLst/>
-              <a:uLnTx/>
-              <a:uFillTx/>
-              <a:latin typeface="TradeGothic"/>
-              <a:ea typeface="+mn-ea"/>
-              <a:cs typeface="+mn-cs"/>
-            </a:endParaRPr>
-          </a:p>
-        </p:txBody>
-      </p:sp>
-      <p:sp>
-        <p:nvSpPr>
-          <p:cNvPr id="3" name="Round Diagonal Corner Rectangle 2"/>
-          <p:cNvSpPr/>
-          <p:nvPr/>
-        </p:nvSpPr>
-        <p:spPr>
-          <a:xfrm>
-            <a:off x="0" y="1791032"/>
-            <a:ext cx="12192000" cy="4319200"/>
-          </a:xfrm>
-          <a:prstGeom prst="round2DiagRect">
-            <a:avLst/>
-          </a:prstGeom>
-          <a:solidFill>
-            <a:schemeClr val="accent1">
-              <a:lumMod val="20000"/>
-              <a:lumOff val="80000"/>
-            </a:schemeClr>
-          </a:solidFill>
-          <a:ln w="38100"/>
-        </p:spPr>
-        <p:style>
-          <a:lnRef idx="1">
-            <a:schemeClr val="accent1"/>
-          </a:lnRef>
-          <a:fillRef idx="3">
-            <a:schemeClr val="accent1"/>
-          </a:fillRef>
-          <a:effectRef idx="2">
-            <a:schemeClr val="accent1"/>
-          </a:effectRef>
-          <a:fontRef idx="minor">
-            <a:schemeClr val="lt1"/>
-          </a:fontRef>
-        </p:style>
-        <p:txBody>
-          <a:bodyPr rtlCol="0" anchor="ctr"/>
-          <a:lstStyle/>
-          <a:p>
-            <a:pPr algn="ctr"/>
-            <a:endParaRPr lang="en-IN"/>
-          </a:p>
-        </p:txBody>
-      </p:sp>
-      <p:sp>
-        <p:nvSpPr>
-          <p:cNvPr id="12" name="Google Shape;100;p3"/>
-          <p:cNvSpPr txBox="1"/>
-          <p:nvPr/>
-        </p:nvSpPr>
-        <p:spPr>
-          <a:xfrm>
-            <a:off x="367832" y="1915454"/>
-            <a:ext cx="11764736" cy="4070356"/>
-          </a:xfrm>
-          <a:prstGeom prst="rect">
-            <a:avLst/>
-          </a:prstGeom>
-          <a:noFill/>
-          <a:ln>
-            <a:noFill/>
-          </a:ln>
-        </p:spPr>
-        <p:txBody>
-          <a:bodyPr spcFirstLastPara="1" wrap="square" lIns="91425" tIns="45700" rIns="91425" bIns="45700" anchor="t" anchorCtr="0">
-            <a:noAutofit/>
-          </a:bodyPr>
-          <a:lstStyle/>
-          <a:p>
-            <a:pPr marL="514350" marR="0" lvl="0" indent="-514350" algn="just" rtl="0">
-              <a:lnSpc>
-                <a:spcPct val="90000"/>
-              </a:lnSpc>
-              <a:spcBef>
-                <a:spcPts val="0"/>
-              </a:spcBef>
-              <a:spcAft>
-                <a:spcPts val="0"/>
-              </a:spcAft>
-              <a:buClr>
-                <a:schemeClr val="dk1"/>
-              </a:buClr>
-              <a:buSzPct val="100000"/>
-              <a:buFont typeface="Calibri"/>
-              <a:buAutoNum type="arabicPeriod"/>
-            </a:pPr>
-            <a:r>
-              <a:rPr lang="en-US" b="1" i="0" u="none" strike="noStrike" cap="none" dirty="0">
-                <a:solidFill>
-                  <a:schemeClr val="dk1"/>
-                </a:solidFill>
-                <a:latin typeface="Arial" panose="020B0604020202020204" pitchFamily="34" charset="0"/>
-                <a:ea typeface="Calibri"/>
-                <a:cs typeface="Arial" panose="020B0604020202020204" pitchFamily="34" charset="0"/>
-                <a:sym typeface="Calibri"/>
-              </a:rPr>
-              <a:t>Kindly keep the maximum slides limit up to six </a:t>
-            </a:r>
-            <a:r>
-              <a:rPr lang="en-US" b="1" i="0" u="none" strike="noStrike" cap="none" dirty="0">
-                <a:solidFill>
-                  <a:srgbClr val="C00000"/>
-                </a:solidFill>
-                <a:latin typeface="Arial" panose="020B0604020202020204" pitchFamily="34" charset="0"/>
-                <a:ea typeface="Calibri"/>
-                <a:cs typeface="Arial" panose="020B0604020202020204" pitchFamily="34" charset="0"/>
-                <a:sym typeface="Calibri"/>
-              </a:rPr>
-              <a:t>(6). </a:t>
-            </a:r>
-            <a:r>
-              <a:rPr lang="en-US" b="1" i="0" u="none" strike="noStrike" cap="none" dirty="0">
-                <a:solidFill>
-                  <a:schemeClr val="dk1"/>
-                </a:solidFill>
-                <a:latin typeface="Arial" panose="020B0604020202020204" pitchFamily="34" charset="0"/>
-                <a:ea typeface="Calibri"/>
-                <a:cs typeface="Arial" panose="020B0604020202020204" pitchFamily="34" charset="0"/>
-                <a:sym typeface="Calibri"/>
-              </a:rPr>
-              <a:t>( Including the </a:t>
-            </a:r>
-            <a:r>
-              <a:rPr lang="en-US" b="1" i="0" u="none" strike="noStrike" cap="none">
-                <a:solidFill>
-                  <a:schemeClr val="dk1"/>
-                </a:solidFill>
-                <a:latin typeface="Arial" panose="020B0604020202020204" pitchFamily="34" charset="0"/>
-                <a:ea typeface="Calibri"/>
-                <a:cs typeface="Arial" panose="020B0604020202020204" pitchFamily="34" charset="0"/>
-                <a:sym typeface="Calibri"/>
-              </a:rPr>
-              <a:t>title slide) </a:t>
-            </a:r>
-            <a:endParaRPr b="1" dirty="0">
-              <a:latin typeface="Arial" panose="020B0604020202020204" pitchFamily="34" charset="0"/>
-              <a:cs typeface="Arial" panose="020B0604020202020204" pitchFamily="34" charset="0"/>
-            </a:endParaRPr>
-          </a:p>
-          <a:p>
-            <a:pPr marL="514350" marR="0" lvl="0" indent="-514350" algn="just" rtl="0">
-              <a:lnSpc>
-                <a:spcPct val="90000"/>
-              </a:lnSpc>
-              <a:spcBef>
-                <a:spcPts val="1000"/>
-              </a:spcBef>
-              <a:spcAft>
-                <a:spcPts val="0"/>
-              </a:spcAft>
-              <a:buClr>
-                <a:schemeClr val="dk1"/>
-              </a:buClr>
-              <a:buSzPct val="100000"/>
-              <a:buFont typeface="Calibri"/>
-              <a:buAutoNum type="arabicPeriod"/>
-            </a:pPr>
-            <a:r>
-              <a:rPr lang="en-US" b="1" i="0" u="none" strike="noStrike" cap="none" dirty="0">
-                <a:solidFill>
-                  <a:schemeClr val="dk1"/>
-                </a:solidFill>
-                <a:latin typeface="Arial" panose="020B0604020202020204" pitchFamily="34" charset="0"/>
-                <a:ea typeface="Calibri"/>
-                <a:cs typeface="Arial" panose="020B0604020202020204" pitchFamily="34" charset="0"/>
-                <a:sym typeface="Calibri"/>
-              </a:rPr>
-              <a:t>Try to avoid paragraphs and post your idea in points /diagrams / Infographics /pictures </a:t>
-            </a:r>
-            <a:endParaRPr b="1" dirty="0">
-              <a:latin typeface="Arial" panose="020B0604020202020204" pitchFamily="34" charset="0"/>
-              <a:cs typeface="Arial" panose="020B0604020202020204" pitchFamily="34" charset="0"/>
-            </a:endParaRPr>
-          </a:p>
-          <a:p>
-            <a:pPr marL="514350" marR="0" lvl="0" indent="-514350" algn="just" rtl="0">
-              <a:lnSpc>
-                <a:spcPct val="90000"/>
-              </a:lnSpc>
-              <a:spcBef>
-                <a:spcPts val="1000"/>
-              </a:spcBef>
-              <a:spcAft>
-                <a:spcPts val="0"/>
-              </a:spcAft>
-              <a:buClr>
-                <a:schemeClr val="dk1"/>
-              </a:buClr>
-              <a:buSzPct val="100000"/>
-              <a:buFont typeface="Calibri"/>
-              <a:buAutoNum type="arabicPeriod"/>
-            </a:pPr>
-            <a:r>
-              <a:rPr lang="en-US" b="1" i="0" u="none" strike="noStrike" cap="none" dirty="0">
-                <a:solidFill>
-                  <a:schemeClr val="dk1"/>
-                </a:solidFill>
-                <a:latin typeface="Arial" panose="020B0604020202020204" pitchFamily="34" charset="0"/>
-                <a:ea typeface="Calibri"/>
-                <a:cs typeface="Arial" panose="020B0604020202020204" pitchFamily="34" charset="0"/>
-                <a:sym typeface="Calibri"/>
-              </a:rPr>
-              <a:t>Keep your explanation precise and easy to understand</a:t>
-            </a:r>
-            <a:endParaRPr b="1" dirty="0">
-              <a:latin typeface="Arial" panose="020B0604020202020204" pitchFamily="34" charset="0"/>
-              <a:cs typeface="Arial" panose="020B0604020202020204" pitchFamily="34" charset="0"/>
-            </a:endParaRPr>
-          </a:p>
-          <a:p>
-            <a:pPr marL="514350" marR="0" lvl="0" indent="-514350" algn="just" rtl="0">
-              <a:lnSpc>
-                <a:spcPct val="90000"/>
-              </a:lnSpc>
-              <a:spcBef>
-                <a:spcPts val="1000"/>
-              </a:spcBef>
-              <a:spcAft>
-                <a:spcPts val="0"/>
-              </a:spcAft>
-              <a:buClr>
-                <a:schemeClr val="dk1"/>
-              </a:buClr>
-              <a:buSzPct val="100000"/>
-              <a:buFont typeface="Calibri"/>
-              <a:buAutoNum type="arabicPeriod"/>
-            </a:pPr>
-            <a:r>
-              <a:rPr lang="en-US" b="1" i="0" u="none" strike="noStrike" cap="none" dirty="0">
-                <a:solidFill>
-                  <a:schemeClr val="dk1"/>
-                </a:solidFill>
-                <a:latin typeface="Arial" panose="020B0604020202020204" pitchFamily="34" charset="0"/>
-                <a:ea typeface="Calibri"/>
-                <a:cs typeface="Arial" panose="020B0604020202020204" pitchFamily="34" charset="0"/>
-                <a:sym typeface="Calibri"/>
-              </a:rPr>
-              <a:t>Idea should be unique and novel. </a:t>
-            </a:r>
-            <a:endParaRPr b="1" dirty="0">
-              <a:latin typeface="Arial" panose="020B0604020202020204" pitchFamily="34" charset="0"/>
-              <a:cs typeface="Arial" panose="020B0604020202020204" pitchFamily="34" charset="0"/>
-            </a:endParaRPr>
-          </a:p>
-          <a:p>
-            <a:pPr marL="514350" marR="0" lvl="0" indent="-514350" algn="just" rtl="0">
-              <a:lnSpc>
-                <a:spcPct val="90000"/>
-              </a:lnSpc>
-              <a:spcBef>
-                <a:spcPts val="1000"/>
-              </a:spcBef>
-              <a:spcAft>
-                <a:spcPts val="0"/>
-              </a:spcAft>
-              <a:buClr>
-                <a:schemeClr val="dk1"/>
-              </a:buClr>
-              <a:buSzPct val="100000"/>
-              <a:buFont typeface="Calibri"/>
-              <a:buAutoNum type="arabicPeriod"/>
-            </a:pPr>
-            <a:r>
-              <a:rPr lang="en-US" b="1" i="0" u="none" strike="noStrike" cap="none" dirty="0">
-                <a:solidFill>
-                  <a:schemeClr val="dk1"/>
-                </a:solidFill>
-                <a:latin typeface="Arial" panose="020B0604020202020204" pitchFamily="34" charset="0"/>
-                <a:ea typeface="Calibri"/>
-                <a:cs typeface="Arial" panose="020B0604020202020204" pitchFamily="34" charset="0"/>
-                <a:sym typeface="Calibri"/>
-              </a:rPr>
-              <a:t>You can only use provided </a:t>
-            </a:r>
-            <a:r>
-              <a:rPr lang="en-US" b="1" dirty="0">
-                <a:solidFill>
-                  <a:schemeClr val="dk1"/>
-                </a:solidFill>
-                <a:latin typeface="Arial" panose="020B0604020202020204" pitchFamily="34" charset="0"/>
-                <a:ea typeface="Calibri"/>
-                <a:cs typeface="Arial" panose="020B0604020202020204" pitchFamily="34" charset="0"/>
-                <a:sym typeface="Calibri"/>
-              </a:rPr>
-              <a:t>template</a:t>
-            </a:r>
-            <a:r>
-              <a:rPr lang="en-US" b="1" i="0" u="none" strike="noStrike" cap="none" dirty="0">
-                <a:solidFill>
-                  <a:schemeClr val="dk1"/>
-                </a:solidFill>
-                <a:latin typeface="Arial" panose="020B0604020202020204" pitchFamily="34" charset="0"/>
-                <a:ea typeface="Calibri"/>
-                <a:cs typeface="Arial" panose="020B0604020202020204" pitchFamily="34" charset="0"/>
-                <a:sym typeface="Calibri"/>
-              </a:rPr>
-              <a:t> for making the </a:t>
-            </a:r>
-            <a:r>
-              <a:rPr lang="en-US" b="1" dirty="0">
-                <a:solidFill>
-                  <a:schemeClr val="dk1"/>
-                </a:solidFill>
-                <a:latin typeface="Arial" panose="020B0604020202020204" pitchFamily="34" charset="0"/>
-                <a:ea typeface="Calibri"/>
-                <a:cs typeface="Arial" panose="020B0604020202020204" pitchFamily="34" charset="0"/>
-                <a:sym typeface="Calibri"/>
-              </a:rPr>
-              <a:t>PPT</a:t>
-            </a:r>
-            <a:r>
-              <a:rPr lang="en-US" b="1" i="0" u="none" strike="noStrike" cap="none" dirty="0">
-                <a:solidFill>
-                  <a:schemeClr val="dk1"/>
-                </a:solidFill>
-                <a:latin typeface="Arial" panose="020B0604020202020204" pitchFamily="34" charset="0"/>
-                <a:ea typeface="Calibri"/>
-                <a:cs typeface="Arial" panose="020B0604020202020204" pitchFamily="34" charset="0"/>
-                <a:sym typeface="Calibri"/>
-              </a:rPr>
-              <a:t> without changing the idea details pointers (mentioned in previous slides).</a:t>
-            </a:r>
-            <a:endParaRPr b="1" i="0" u="none" strike="noStrike" cap="none" dirty="0">
-              <a:solidFill>
-                <a:schemeClr val="dk1"/>
-              </a:solidFill>
-              <a:latin typeface="Arial" panose="020B0604020202020204" pitchFamily="34" charset="0"/>
-              <a:ea typeface="Calibri"/>
-              <a:cs typeface="Arial" panose="020B0604020202020204" pitchFamily="34" charset="0"/>
-              <a:sym typeface="Calibri"/>
-            </a:endParaRPr>
-          </a:p>
-          <a:p>
-            <a:pPr marL="514350" marR="0" lvl="0" indent="-514350" algn="just" rtl="0">
-              <a:lnSpc>
-                <a:spcPct val="90000"/>
-              </a:lnSpc>
-              <a:spcBef>
-                <a:spcPts val="1000"/>
-              </a:spcBef>
-              <a:spcAft>
-                <a:spcPts val="0"/>
-              </a:spcAft>
-              <a:buClr>
-                <a:schemeClr val="dk1"/>
-              </a:buClr>
-              <a:buSzPct val="100000"/>
-              <a:buFont typeface="Calibri"/>
-              <a:buAutoNum type="arabicPeriod"/>
-            </a:pPr>
-            <a:r>
-              <a:rPr lang="en-US" b="1" i="0" u="none" strike="noStrike" cap="none" dirty="0">
-                <a:solidFill>
-                  <a:schemeClr val="dk1"/>
-                </a:solidFill>
-                <a:latin typeface="Arial" panose="020B0604020202020204" pitchFamily="34" charset="0"/>
-                <a:ea typeface="Calibri"/>
-                <a:cs typeface="Arial" panose="020B0604020202020204" pitchFamily="34" charset="0"/>
-                <a:sym typeface="Calibri"/>
-              </a:rPr>
-              <a:t>You need to save the file in PDF and upload the same on portal. No PPT, Word Doc or any other format will be supported.</a:t>
-            </a:r>
-            <a:endParaRPr b="1" dirty="0">
-              <a:latin typeface="Arial" panose="020B0604020202020204" pitchFamily="34" charset="0"/>
-              <a:cs typeface="Arial" panose="020B0604020202020204" pitchFamily="34" charset="0"/>
-            </a:endParaRPr>
-          </a:p>
-          <a:p>
-            <a:pPr marL="514350" marR="0" lvl="0" indent="-349885" algn="just" rtl="0">
-              <a:lnSpc>
-                <a:spcPct val="90000"/>
-              </a:lnSpc>
-              <a:spcBef>
-                <a:spcPts val="1000"/>
-              </a:spcBef>
-              <a:spcAft>
-                <a:spcPts val="0"/>
-              </a:spcAft>
-              <a:buClr>
-                <a:schemeClr val="dk1"/>
-              </a:buClr>
-              <a:buSzPct val="100000"/>
-              <a:buFont typeface="Calibri"/>
-              <a:buNone/>
-            </a:pPr>
-            <a:endParaRPr b="1" i="0" u="none" strike="noStrike" cap="none" dirty="0">
-              <a:solidFill>
-                <a:schemeClr val="dk1"/>
-              </a:solidFill>
-              <a:latin typeface="Arial" panose="020B0604020202020204" pitchFamily="34" charset="0"/>
-              <a:ea typeface="Calibri"/>
-              <a:cs typeface="Arial" panose="020B0604020202020204" pitchFamily="34" charset="0"/>
-              <a:sym typeface="Calibri"/>
-            </a:endParaRPr>
-          </a:p>
-          <a:p>
-            <a:pPr marL="0" marR="0" lvl="0" indent="0" algn="just" rtl="0">
-              <a:lnSpc>
-                <a:spcPct val="90000"/>
-              </a:lnSpc>
-              <a:spcBef>
-                <a:spcPts val="1000"/>
-              </a:spcBef>
-              <a:spcAft>
-                <a:spcPts val="0"/>
-              </a:spcAft>
-              <a:buClr>
-                <a:schemeClr val="dk1"/>
-              </a:buClr>
-              <a:buSzPct val="100000"/>
-              <a:buFont typeface="Arial"/>
-              <a:buNone/>
-            </a:pPr>
-            <a:r>
-              <a:rPr lang="en-US" b="1" i="0" u="none" strike="noStrike" cap="none" dirty="0">
-                <a:solidFill>
-                  <a:srgbClr val="C00000"/>
-                </a:solidFill>
-                <a:latin typeface="Arial" panose="020B0604020202020204" pitchFamily="34" charset="0"/>
-                <a:ea typeface="Calibri"/>
-                <a:cs typeface="Arial" panose="020B0604020202020204" pitchFamily="34" charset="0"/>
-                <a:sym typeface="Calibri"/>
-              </a:rPr>
-              <a:t>Note - You can delete this slide (Important Pointers) when you upload the details of your idea on SIH portal.</a:t>
-            </a:r>
-            <a:endParaRPr b="1" dirty="0">
-              <a:solidFill>
-                <a:srgbClr val="C00000"/>
-              </a:solidFill>
-              <a:latin typeface="Arial" panose="020B0604020202020204" pitchFamily="34" charset="0"/>
-              <a:cs typeface="Arial" panose="020B0604020202020204" pitchFamily="34" charset="0"/>
-            </a:endParaRPr>
-          </a:p>
-          <a:p>
-            <a:pPr marL="914400" marR="0" lvl="1" indent="-316230" algn="just" rtl="0">
-              <a:lnSpc>
-                <a:spcPct val="90000"/>
-              </a:lnSpc>
-              <a:spcBef>
-                <a:spcPts val="500"/>
-              </a:spcBef>
-              <a:spcAft>
-                <a:spcPts val="0"/>
-              </a:spcAft>
-              <a:buClr>
-                <a:schemeClr val="dk1"/>
-              </a:buClr>
-              <a:buSzPct val="100000"/>
-              <a:buFont typeface="Calibri"/>
-              <a:buNone/>
-            </a:pPr>
-            <a:endParaRPr sz="2000" b="1" i="0" u="none" strike="noStrike" cap="none" dirty="0">
-              <a:solidFill>
-                <a:schemeClr val="dk1"/>
-              </a:solidFill>
-              <a:latin typeface="Arial" panose="020B0604020202020204" pitchFamily="34" charset="0"/>
-              <a:ea typeface="Calibri"/>
-              <a:cs typeface="Arial" panose="020B0604020202020204" pitchFamily="34" charset="0"/>
-              <a:sym typeface="Calibri"/>
-            </a:endParaRPr>
-          </a:p>
-        </p:txBody>
-      </p:sp>
-      <p:sp>
-        <p:nvSpPr>
-          <p:cNvPr id="4" name="TextBox 3"/>
-          <p:cNvSpPr txBox="1"/>
-          <p:nvPr/>
-        </p:nvSpPr>
-        <p:spPr>
-          <a:xfrm>
-            <a:off x="1393371" y="107066"/>
-            <a:ext cx="8410540" cy="646331"/>
-          </a:xfrm>
-          <a:prstGeom prst="rect">
-            <a:avLst/>
-          </a:prstGeom>
-          <a:noFill/>
-        </p:spPr>
-        <p:txBody>
-          <a:bodyPr wrap="square" rtlCol="0">
-            <a:spAutoFit/>
-          </a:bodyPr>
-          <a:lstStyle/>
-          <a:p>
-            <a:pPr algn="ctr"/>
-            <a:r>
-              <a:rPr lang="en-US" sz="3600" b="1" dirty="0">
-                <a:latin typeface="Times New Roman" panose="02020603050405020304" pitchFamily="18" charset="0"/>
-                <a:cs typeface="Times New Roman" panose="02020603050405020304" pitchFamily="18" charset="0"/>
-              </a:rPr>
-              <a:t>IMPORTANT INSTRUCTIONS</a:t>
-            </a:r>
-            <a:endParaRPr lang="en-IN" sz="3600" b="1" dirty="0">
-              <a:latin typeface="Times New Roman" panose="02020603050405020304" pitchFamily="18" charset="0"/>
-              <a:cs typeface="Times New Roman" panose="02020603050405020304" pitchFamily="18" charset="0"/>
-            </a:endParaRPr>
-          </a:p>
-        </p:txBody>
-      </p:sp>
-      <p:sp>
-        <p:nvSpPr>
-          <p:cNvPr id="5" name="TextBox 4"/>
-          <p:cNvSpPr txBox="1"/>
-          <p:nvPr/>
-        </p:nvSpPr>
-        <p:spPr>
-          <a:xfrm>
-            <a:off x="602343" y="1181900"/>
-            <a:ext cx="9557657" cy="341632"/>
-          </a:xfrm>
-          <a:prstGeom prst="rect">
-            <a:avLst/>
-          </a:prstGeom>
-          <a:noFill/>
-        </p:spPr>
-        <p:txBody>
-          <a:bodyPr wrap="square" rtlCol="0">
-            <a:spAutoFit/>
-          </a:bodyPr>
-          <a:lstStyle/>
-          <a:p>
-            <a:pPr algn="just">
-              <a:lnSpc>
-                <a:spcPct val="90000"/>
-              </a:lnSpc>
-              <a:spcBef>
-                <a:spcPts val="1000"/>
-              </a:spcBef>
-              <a:spcAft>
-                <a:spcPts val="0"/>
-              </a:spcAft>
-              <a:buClr>
-                <a:schemeClr val="dk1"/>
-              </a:buClr>
-              <a:buSzPct val="100000"/>
-            </a:pPr>
-            <a:r>
-              <a:rPr lang="en-US" b="1" dirty="0">
-                <a:solidFill>
-                  <a:schemeClr val="dk1"/>
-                </a:solidFill>
-                <a:latin typeface="Arial" panose="020B0604020202020204" pitchFamily="34" charset="0"/>
-                <a:ea typeface="Calibri"/>
-                <a:cs typeface="Arial" panose="020B0604020202020204" pitchFamily="34" charset="0"/>
-              </a:rPr>
-              <a:t>Please ensure below pointers are met while submitting the Idea PPT:</a:t>
-            </a:r>
-            <a:endParaRPr lang="en-IN" b="1" dirty="0">
-              <a:solidFill>
-                <a:schemeClr val="dk1"/>
-              </a:solidFill>
-              <a:latin typeface="Arial" panose="020B0604020202020204" pitchFamily="34" charset="0"/>
-              <a:ea typeface="Calibri"/>
-              <a:cs typeface="Arial" panose="020B0604020202020204" pitchFamily="34" charset="0"/>
-            </a:endParaRPr>
-          </a:p>
-        </p:txBody>
-      </p:sp>
-      <p:pic>
-        <p:nvPicPr>
-          <p:cNvPr id="13" name="Picture 12"/>
-          <p:cNvPicPr>
-            <a:picLocks noChangeAspect="1"/>
-          </p:cNvPicPr>
-          <p:nvPr/>
-        </p:nvPicPr>
-        <p:blipFill>
-          <a:blip r:embed="rId3">
-            <a:extLst>
-              <a:ext uri="{28A0092B-C50C-407E-A947-70E740481C1C}">
-                <a14:useLocalDpi xmlns:a14="http://schemas.microsoft.com/office/drawing/2010/main" val="0"/>
-              </a:ext>
-            </a:extLst>
-          </a:blip>
-          <a:stretch>
-            <a:fillRect/>
-          </a:stretch>
-        </p:blipFill>
-        <p:spPr>
-          <a:xfrm>
-            <a:off x="9780086" y="1500"/>
-            <a:ext cx="2249850" cy="1062337"/>
-          </a:xfrm>
-          <a:prstGeom prst="rect">
-            <a:avLst/>
-          </a:prstGeom>
-        </p:spPr>
-      </p:pic>
-    </p:spTree>
-    <p:extLst>
-      <p:ext uri="{BB962C8B-B14F-4D97-AF65-F5344CB8AC3E}">
-        <p14:creationId xmlns:p14="http://schemas.microsoft.com/office/powerpoint/2010/main" val="1588084416"/>
       </p:ext>
     </p:extLst>
   </p:cSld>

</xml_diff>